<commit_message>
Final deliverables from merged main: screenshots, demo log, deck
Run on main after PRs #1, #3, #5 and #6, fresh database and index:
- deliverables/screenshots/: 11 screenshots of the walk-through
- deliverables/demo_transcript.md + execution_trace_log.md: scripted
  demo, session demo-final (6 questions; the chat add/drop question is
  left out because it fails with "An explicit term is required"; add /
  drop is shown on the Plan screen instead)
- deck rebuilt from these: 30 slides in the course template's outline,
  facts updated (plan to graduation in Spring 2029 with projected terms,
  141 prerequisite rules, 82 tests with CI)

The six-checks demo now uses CSE 3320 in Spring 2027 (all six pass);
the eligibility question gives the term as "S2027", since "next
semester" is read as the current term.

Co-Authored-By: Claude Opus 5.5 <noreply@anthropic.com>
</commit_message>
<xml_diff>
--- a/deliverables/AI_Advisor_Presentation.pptx
+++ b/deliverables/AI_Advisor_Presentation.pptx
@@ -1316,7 +1316,7 @@
           </a:p>
           <a:p>
             <a:r>
-              <a:t>What it means: The planner fills semesters in prerequisite order within the 15-credit cap; the rings show what each area still needs.</a:t>
+              <a:t>What it means: Graduation in Spring 2029, in prerequisite order within the 15-credit cap; terms after Summer 2027 are projected.</a:t>
             </a:r>
           </a:p>
         </p:txBody>
@@ -1456,7 +1456,7 @@
           <a:lstStyle/>
           <a:p>
             <a:r>
-              <a:t>Input: Check a course: CSE 4344, Spring 2027</a:t>
+              <a:t>Input: Check a course: CSE 3320, Spring 2027</a:t>
             </a:r>
           </a:p>
           <a:p>
@@ -1466,7 +1466,7 @@
           </a:p>
           <a:p>
             <a:r>
-              <a:t>What it means: A course is only recommended if all six pass; the reasons tell the student exactly what to fix.</a:t>
+              <a:t>What it means: All six pass for the course the planner chose for Spring 2027; any failure blocks a recommendation and says what to fix.</a:t>
             </a:r>
           </a:p>
         </p:txBody>
@@ -1541,7 +1541,7 @@
           </a:p>
           <a:p>
             <a:r>
-              <a:t>Output: Five checks pass; (e) fails at 17 of 15 semester credits, so Add stays disabled</a:t>
+              <a:t>Output: Three checks fail: it doesn’t count toward the degree, 17 of 15 semester credits, 124 of 123 degree credits. Add stays disabled</a:t>
             </a:r>
           </a:p>
           <a:p>
@@ -12158,7 +12158,7 @@
                 </a:solidFill>
                 <a:latin typeface="Arial"/>
               </a:rPr>
-              <a:t>Demo · Req 2: a degree plan</a:t>
+              <a:t>Demo · Req 2: a multi-year plan to graduation</a:t>
             </a:r>
           </a:p>
         </p:txBody>
@@ -12173,7 +12173,7 @@
         </p:nvPicPr>
         <p:blipFill>
           <a:blip r:embed="rId2"/>
-          <a:srcRect l="13000" r="13000" t="47000" b="9027"/>
+          <a:srcRect l="13000" r="13000" t="47000" b="12261"/>
           <a:stretch>
             <a:fillRect/>
           </a:stretch>
@@ -12422,7 +12422,7 @@
                 </a:solidFill>
                 <a:latin typeface="Arial"/>
               </a:rPr>
-              <a:t>The planner fills semesters in prerequisite order within the 15-credit cap; the rings show what each area still needs.</a:t>
+              <a:t>Graduation in Spring 2029, in prerequisite order within the 15-credit cap; terms after Summer 2027 are projected.</a:t>
             </a:r>
           </a:p>
         </p:txBody>
@@ -13512,7 +13512,7 @@
                 </a:solidFill>
                 <a:latin typeface="Arial"/>
               </a:rPr>
-              <a:t>Check a course: CSE 4344, Spring 2027</a:t>
+              <a:t>Check a course: CSE 3320, Spring 2027</a:t>
             </a:r>
           </a:p>
         </p:txBody>
@@ -13668,7 +13668,7 @@
                 </a:solidFill>
                 <a:latin typeface="Arial"/>
               </a:rPr>
-              <a:t>A course is only recommended if all six pass; the reasons tell the student exactly what to fix.</a:t>
+              <a:t>All six pass for the course the planner chose for Spring 2027; any failure blocks a recommendation and says what to fix.</a:t>
             </a:r>
           </a:p>
         </p:txBody>
@@ -13958,7 +13958,7 @@
                 </a:solidFill>
                 <a:latin typeface="Arial"/>
               </a:rPr>
-              <a:t>Five checks pass; (e) fails at 17 of 15 semester credits, so Add stays disabled</a:t>
+              <a:t>Three checks fail: it doesn’t count toward the degree, 17 of 15 semester credits, 124 of 123 degree credits. Add stays disabled</a:t>
             </a:r>
           </a:p>
         </p:txBody>
@@ -14891,7 +14891,7 @@
         </p:nvPicPr>
         <p:blipFill>
           <a:blip r:embed="rId2"/>
-          <a:srcRect l="13000" r="13000" t="17000" b="29464"/>
+          <a:srcRect l="13000" r="13000" t="17000" b="42067"/>
           <a:stretch>
             <a:fillRect/>
           </a:stretch>
@@ -15758,7 +15758,7 @@
                 </a:solidFill>
                 <a:latin typeface="Arial"/>
               </a:rPr>
-              <a:t>Check a course: CSE 4344, Spring 2027</a:t>
+              <a:t>Check a course: CSE 3320, Spring 2027</a:t>
             </a:r>
           </a:p>
           <a:p>
@@ -16767,7 +16767,7 @@
                 </a:solidFill>
                 <a:latin typeface="Arial"/>
               </a:rPr>
-              <a:t>89 automated tests</a:t>
+              <a:t>82 automated tests</a:t>
             </a:r>
             <a:r>
               <a:rPr sz="1700" b="0">
@@ -16776,7 +16776,7 @@
                 </a:solidFill>
                 <a:latin typeface="Arial"/>
               </a:rPr>
-              <a:t> across planner, router, RAG retrieval, data schema, UI services, and tracing</a:t>
+              <a:t> across planner, router, RAG retrieval, data schema, UI services, and tracing; run with a linter on every pull request</a:t>
             </a:r>
           </a:p>
           <a:p>
@@ -17765,7 +17765,7 @@
                 </a:solidFill>
                 <a:latin typeface="Arial"/>
               </a:rPr>
-              <a:t>Every branch tested together before the final merge</a:t>
+              <a:t>Every branch tested together before the final merge; tests and lint run on every pull request</a:t>
             </a:r>
           </a:p>
           <a:p>
@@ -18091,7 +18091,26 @@
                 </a:solidFill>
                 <a:latin typeface="Arial"/>
               </a:rPr>
-              <a:t>Plan past the published schedule using each course’s usual terms</a:t>
+              <a:t>Chat: add / drop by message, “next semester” as the next term, progress questions</a:t>
+            </a:r>
+          </a:p>
+          <a:p>
+            <a:pPr algn="l">
+              <a:lnSpc>
+                <a:spcPct val="120000"/>
+              </a:lnSpc>
+              <a:spcAft>
+                <a:spcPts val="600"/>
+              </a:spcAft>
+            </a:pPr>
+            <a:r>
+              <a:rPr sz="1500" b="0">
+                <a:solidFill>
+                  <a:srgbClr val="1D1D1F"/>
+                </a:solidFill>
+                <a:latin typeface="Arial"/>
+              </a:rPr>
+              <a:t>Make exploring a switch read-only until the student confirms</a:t>
             </a:r>
           </a:p>
           <a:p>
@@ -20353,7 +20372,7 @@
                 </a:solidFill>
                 <a:latin typeface="Arial"/>
               </a:rPr>
-              <a:t> sections are published for three terms (Fall 2026 – Summer 2027)</a:t>
+              <a:t> sections exist for Fall 2026 – Summer 2027; later terms are projected from catalog offering patterns</a:t>
             </a:r>
           </a:p>
         </p:txBody>
@@ -26044,7 +26063,7 @@
                 </a:solidFill>
                 <a:latin typeface="Arial"/>
               </a:rPr>
-              <a:t>132 prerequisite rules</a:t>
+              <a:t>141 prerequisite rules</a:t>
             </a:r>
             <a:r>
               <a:rPr sz="1500" b="0">
@@ -26053,7 +26072,7 @@
                 </a:solidFill>
                 <a:latin typeface="Arial"/>
               </a:rPr>
-              <a:t> (OR groups, minimum grades, same-term allowed)</a:t>
+              <a:t> (OR groups, minimum grades; 21 may be taken the same term)</a:t>
             </a:r>
           </a:p>
           <a:p>

</xml_diff>

<commit_message>
Leave speaker notes out of the deck by default
The notes stay in scripts/build_slides.py; --notes writes them into
the deck when the team wants them back.

Co-Authored-By: Claude Opus 5.5 <noreply@anthropic.com>
</commit_message>
<xml_diff>
--- a/deliverables/AI_Advisor_Presentation.pptx
+++ b/deliverables/AI_Advisor_Presentation.pptx
@@ -6,35 +6,35 @@
   </p:sldMasterIdLst>
   <p:sldIdLst>
     <p:sldId id="256" r:id="rId7"/>
-    <p:sldId id="257" r:id="rId9"/>
-    <p:sldId id="258" r:id="rId10"/>
-    <p:sldId id="259" r:id="rId11"/>
-    <p:sldId id="260" r:id="rId12"/>
-    <p:sldId id="261" r:id="rId13"/>
-    <p:sldId id="262" r:id="rId14"/>
-    <p:sldId id="263" r:id="rId15"/>
-    <p:sldId id="264" r:id="rId16"/>
-    <p:sldId id="265" r:id="rId17"/>
-    <p:sldId id="266" r:id="rId18"/>
-    <p:sldId id="267" r:id="rId19"/>
-    <p:sldId id="268" r:id="rId20"/>
-    <p:sldId id="269" r:id="rId21"/>
-    <p:sldId id="270" r:id="rId22"/>
-    <p:sldId id="271" r:id="rId23"/>
-    <p:sldId id="272" r:id="rId24"/>
-    <p:sldId id="273" r:id="rId25"/>
-    <p:sldId id="274" r:id="rId26"/>
-    <p:sldId id="275" r:id="rId27"/>
-    <p:sldId id="276" r:id="rId28"/>
-    <p:sldId id="277" r:id="rId29"/>
-    <p:sldId id="278" r:id="rId30"/>
-    <p:sldId id="279" r:id="rId31"/>
-    <p:sldId id="280" r:id="rId32"/>
-    <p:sldId id="281" r:id="rId33"/>
-    <p:sldId id="282" r:id="rId34"/>
-    <p:sldId id="283" r:id="rId35"/>
-    <p:sldId id="284" r:id="rId36"/>
-    <p:sldId id="285" r:id="rId37"/>
+    <p:sldId id="257" r:id="rId8"/>
+    <p:sldId id="258" r:id="rId9"/>
+    <p:sldId id="259" r:id="rId10"/>
+    <p:sldId id="260" r:id="rId11"/>
+    <p:sldId id="261" r:id="rId12"/>
+    <p:sldId id="262" r:id="rId13"/>
+    <p:sldId id="263" r:id="rId14"/>
+    <p:sldId id="264" r:id="rId15"/>
+    <p:sldId id="265" r:id="rId16"/>
+    <p:sldId id="266" r:id="rId17"/>
+    <p:sldId id="267" r:id="rId18"/>
+    <p:sldId id="268" r:id="rId19"/>
+    <p:sldId id="269" r:id="rId20"/>
+    <p:sldId id="270" r:id="rId21"/>
+    <p:sldId id="271" r:id="rId22"/>
+    <p:sldId id="272" r:id="rId23"/>
+    <p:sldId id="273" r:id="rId24"/>
+    <p:sldId id="274" r:id="rId25"/>
+    <p:sldId id="275" r:id="rId26"/>
+    <p:sldId id="276" r:id="rId27"/>
+    <p:sldId id="277" r:id="rId28"/>
+    <p:sldId id="278" r:id="rId29"/>
+    <p:sldId id="279" r:id="rId30"/>
+    <p:sldId id="280" r:id="rId31"/>
+    <p:sldId id="281" r:id="rId32"/>
+    <p:sldId id="282" r:id="rId33"/>
+    <p:sldId id="283" r:id="rId34"/>
+    <p:sldId id="284" r:id="rId35"/>
+    <p:sldId id="285" r:id="rId36"/>
   </p:sldIdLst>
   <p:sldSz cx="12191695" cy="6858000" type="screen4x3"/>
   <p:notesSz cx="6858000" cy="9144000"/>
@@ -134,2686 +134,6 @@
     </a:lvl9pPr>
   </p:defaultTextStyle>
 </p:presentation>
-</file>
-
-<file path=ppt/notesMasters/notesMaster1.xml><?xml version="1.0" encoding="utf-8"?>
-<p:notesMaster xmlns:a="http://schemas.openxmlformats.org/drawingml/2006/main" xmlns:p="http://schemas.openxmlformats.org/presentationml/2006/main" xmlns:r="http://schemas.openxmlformats.org/officeDocument/2006/relationships">
-  <p:cSld>
-    <p:bg>
-      <p:bgRef idx="1001">
-        <a:schemeClr val="bg1"/>
-      </p:bgRef>
-    </p:bg>
-    <p:spTree>
-      <p:nvGrpSpPr>
-        <p:cNvPr id="1" name=""/>
-        <p:cNvGrpSpPr/>
-        <p:nvPr/>
-      </p:nvGrpSpPr>
-      <p:grpSpPr>
-        <a:xfrm>
-          <a:off x="0" y="0"/>
-          <a:ext cx="0" cy="0"/>
-          <a:chOff x="0" y="0"/>
-          <a:chExt cx="0" cy="0"/>
-        </a:xfrm>
-      </p:grpSpPr>
-      <p:sp>
-        <p:nvSpPr>
-          <p:cNvPr id="2" name="Header Placeholder 1"/>
-          <p:cNvSpPr>
-            <a:spLocks noGrp="1"/>
-          </p:cNvSpPr>
-          <p:nvPr>
-            <p:ph type="hdr" sz="quarter"/>
-          </p:nvPr>
-        </p:nvSpPr>
-        <p:spPr>
-          <a:xfrm>
-            <a:off x="0" y="0"/>
-            <a:ext cx="2971800" cy="457200"/>
-          </a:xfrm>
-          <a:prstGeom prst="rect">
-            <a:avLst/>
-          </a:prstGeom>
-        </p:spPr>
-        <p:txBody>
-          <a:bodyPr vert="horz" lIns="91440" tIns="45720" rIns="91440" bIns="45720" rtlCol="0"/>
-          <a:lstStyle>
-            <a:lvl1pPr algn="l">
-              <a:defRPr sz="1200"/>
-            </a:lvl1pPr>
-          </a:lstStyle>
-          <a:p>
-            <a:endParaRPr lang="en-US"/>
-          </a:p>
-        </p:txBody>
-      </p:sp>
-      <p:sp>
-        <p:nvSpPr>
-          <p:cNvPr id="3" name="Date Placeholder 2"/>
-          <p:cNvSpPr>
-            <a:spLocks noGrp="1"/>
-          </p:cNvSpPr>
-          <p:nvPr>
-            <p:ph type="dt" idx="1"/>
-          </p:nvPr>
-        </p:nvSpPr>
-        <p:spPr>
-          <a:xfrm>
-            <a:off x="3884613" y="0"/>
-            <a:ext cx="2971800" cy="457200"/>
-          </a:xfrm>
-          <a:prstGeom prst="rect">
-            <a:avLst/>
-          </a:prstGeom>
-        </p:spPr>
-        <p:txBody>
-          <a:bodyPr vert="horz" lIns="91440" tIns="45720" rIns="91440" bIns="45720" rtlCol="0"/>
-          <a:lstStyle>
-            <a:lvl1pPr algn="r">
-              <a:defRPr sz="1200"/>
-            </a:lvl1pPr>
-          </a:lstStyle>
-          <a:p>
-            <a:fld id="{0F89C1C7-3DCD-1040-A9CF-14679D8B5DDD}" type="datetimeFigureOut">
-              <a:rPr lang="en-US" smtClean="0"/>
-              <a:t>10/17/16</a:t>
-            </a:fld>
-            <a:endParaRPr lang="en-US"/>
-          </a:p>
-        </p:txBody>
-      </p:sp>
-      <p:sp>
-        <p:nvSpPr>
-          <p:cNvPr id="4" name="Slide Image Placeholder 3"/>
-          <p:cNvSpPr>
-            <a:spLocks noGrp="1" noRot="1" noChangeAspect="1"/>
-          </p:cNvSpPr>
-          <p:nvPr>
-            <p:ph type="sldImg" idx="2"/>
-          </p:nvPr>
-        </p:nvSpPr>
-        <p:spPr>
-          <a:xfrm>
-            <a:off x="1143000" y="685800"/>
-            <a:ext cx="4572000" cy="3429000"/>
-          </a:xfrm>
-          <a:prstGeom prst="rect">
-            <a:avLst/>
-          </a:prstGeom>
-          <a:noFill/>
-          <a:ln w="12700">
-            <a:solidFill>
-              <a:prstClr val="black"/>
-            </a:solidFill>
-          </a:ln>
-        </p:spPr>
-        <p:txBody>
-          <a:bodyPr vert="horz" lIns="91440" tIns="45720" rIns="91440" bIns="45720" rtlCol="0" anchor="ctr"/>
-          <a:lstStyle/>
-          <a:p>
-            <a:endParaRPr lang="en-US"/>
-          </a:p>
-        </p:txBody>
-      </p:sp>
-      <p:sp>
-        <p:nvSpPr>
-          <p:cNvPr id="5" name="Notes Placeholder 4"/>
-          <p:cNvSpPr>
-            <a:spLocks noGrp="1"/>
-          </p:cNvSpPr>
-          <p:nvPr>
-            <p:ph type="body" sz="quarter" idx="3"/>
-          </p:nvPr>
-        </p:nvSpPr>
-        <p:spPr>
-          <a:xfrm>
-            <a:off x="685800" y="4343400"/>
-            <a:ext cx="5486400" cy="4114800"/>
-          </a:xfrm>
-          <a:prstGeom prst="rect">
-            <a:avLst/>
-          </a:prstGeom>
-        </p:spPr>
-        <p:txBody>
-          <a:bodyPr vert="horz" lIns="91440" tIns="45720" rIns="91440" bIns="45720" rtlCol="0"/>
-          <a:lstStyle/>
-          <a:p>
-            <a:pPr lvl="0"/>
-            <a:r>
-              <a:rPr lang="en-US" smtClean="0"/>
-              <a:t>Click to edit Master text styles</a:t>
-            </a:r>
-          </a:p>
-          <a:p>
-            <a:pPr lvl="1"/>
-            <a:r>
-              <a:rPr lang="en-US" smtClean="0"/>
-              <a:t>Second level</a:t>
-            </a:r>
-          </a:p>
-          <a:p>
-            <a:pPr lvl="2"/>
-            <a:r>
-              <a:rPr lang="en-US" smtClean="0"/>
-              <a:t>Third level</a:t>
-            </a:r>
-          </a:p>
-          <a:p>
-            <a:pPr lvl="3"/>
-            <a:r>
-              <a:rPr lang="en-US" smtClean="0"/>
-              <a:t>Fourth level</a:t>
-            </a:r>
-          </a:p>
-          <a:p>
-            <a:pPr lvl="4"/>
-            <a:r>
-              <a:rPr lang="en-US" smtClean="0"/>
-              <a:t>Fifth level</a:t>
-            </a:r>
-            <a:endParaRPr lang="en-US"/>
-          </a:p>
-        </p:txBody>
-      </p:sp>
-      <p:sp>
-        <p:nvSpPr>
-          <p:cNvPr id="6" name="Footer Placeholder 5"/>
-          <p:cNvSpPr>
-            <a:spLocks noGrp="1"/>
-          </p:cNvSpPr>
-          <p:nvPr>
-            <p:ph type="ftr" sz="quarter" idx="4"/>
-          </p:nvPr>
-        </p:nvSpPr>
-        <p:spPr>
-          <a:xfrm>
-            <a:off x="0" y="8685213"/>
-            <a:ext cx="2971800" cy="457200"/>
-          </a:xfrm>
-          <a:prstGeom prst="rect">
-            <a:avLst/>
-          </a:prstGeom>
-        </p:spPr>
-        <p:txBody>
-          <a:bodyPr vert="horz" lIns="91440" tIns="45720" rIns="91440" bIns="45720" rtlCol="0" anchor="b"/>
-          <a:lstStyle>
-            <a:lvl1pPr algn="l">
-              <a:defRPr sz="1200"/>
-            </a:lvl1pPr>
-          </a:lstStyle>
-          <a:p>
-            <a:endParaRPr lang="en-US"/>
-          </a:p>
-        </p:txBody>
-      </p:sp>
-      <p:sp>
-        <p:nvSpPr>
-          <p:cNvPr id="7" name="Slide Number Placeholder 6"/>
-          <p:cNvSpPr>
-            <a:spLocks noGrp="1"/>
-          </p:cNvSpPr>
-          <p:nvPr>
-            <p:ph type="sldNum" sz="quarter" idx="5"/>
-          </p:nvPr>
-        </p:nvSpPr>
-        <p:spPr>
-          <a:xfrm>
-            <a:off x="3884613" y="8685213"/>
-            <a:ext cx="2971800" cy="457200"/>
-          </a:xfrm>
-          <a:prstGeom prst="rect">
-            <a:avLst/>
-          </a:prstGeom>
-        </p:spPr>
-        <p:txBody>
-          <a:bodyPr vert="horz" lIns="91440" tIns="45720" rIns="91440" bIns="45720" rtlCol="0" anchor="b"/>
-          <a:lstStyle>
-            <a:lvl1pPr algn="r">
-              <a:defRPr sz="1200"/>
-            </a:lvl1pPr>
-          </a:lstStyle>
-          <a:p>
-            <a:fld id="{BB5E49A5-4136-284D-997B-48E1D791AD67}" type="slidenum">
-              <a:rPr lang="en-US" smtClean="0"/>
-              <a:t>‹#›</a:t>
-            </a:fld>
-            <a:endParaRPr lang="en-US"/>
-          </a:p>
-        </p:txBody>
-      </p:sp>
-    </p:spTree>
-    <p:extLst>
-      <p:ext uri="{BB962C8B-B14F-4D97-AF65-F5344CB8AC3E}">
-        <p14:creationId xmlns:p14="http://schemas.microsoft.com/office/powerpoint/2010/main" val="2623252185"/>
-      </p:ext>
-    </p:extLst>
-  </p:cSld>
-  <p:clrMap bg1="lt1" tx1="dk1" bg2="lt2" tx2="dk2" accent1="accent1" accent2="accent2" accent3="accent3" accent4="accent4" accent5="accent5" accent6="accent6" hlink="hlink" folHlink="folHlink"/>
-  <p:notesStyle>
-    <a:lvl1pPr marL="0" algn="l" defTabSz="457200" rtl="0" eaLnBrk="1" latinLnBrk="0" hangingPunct="1">
-      <a:defRPr sz="1200" kern="1200">
-        <a:solidFill>
-          <a:schemeClr val="tx1"/>
-        </a:solidFill>
-        <a:latin typeface="+mn-lt"/>
-        <a:ea typeface="+mn-ea"/>
-        <a:cs typeface="+mn-cs"/>
-      </a:defRPr>
-    </a:lvl1pPr>
-    <a:lvl2pPr marL="457200" algn="l" defTabSz="457200" rtl="0" eaLnBrk="1" latinLnBrk="0" hangingPunct="1">
-      <a:defRPr sz="1200" kern="1200">
-        <a:solidFill>
-          <a:schemeClr val="tx1"/>
-        </a:solidFill>
-        <a:latin typeface="+mn-lt"/>
-        <a:ea typeface="+mn-ea"/>
-        <a:cs typeface="+mn-cs"/>
-      </a:defRPr>
-    </a:lvl2pPr>
-    <a:lvl3pPr marL="914400" algn="l" defTabSz="457200" rtl="0" eaLnBrk="1" latinLnBrk="0" hangingPunct="1">
-      <a:defRPr sz="1200" kern="1200">
-        <a:solidFill>
-          <a:schemeClr val="tx1"/>
-        </a:solidFill>
-        <a:latin typeface="+mn-lt"/>
-        <a:ea typeface="+mn-ea"/>
-        <a:cs typeface="+mn-cs"/>
-      </a:defRPr>
-    </a:lvl3pPr>
-    <a:lvl4pPr marL="1371600" algn="l" defTabSz="457200" rtl="0" eaLnBrk="1" latinLnBrk="0" hangingPunct="1">
-      <a:defRPr sz="1200" kern="1200">
-        <a:solidFill>
-          <a:schemeClr val="tx1"/>
-        </a:solidFill>
-        <a:latin typeface="+mn-lt"/>
-        <a:ea typeface="+mn-ea"/>
-        <a:cs typeface="+mn-cs"/>
-      </a:defRPr>
-    </a:lvl4pPr>
-    <a:lvl5pPr marL="1828800" algn="l" defTabSz="457200" rtl="0" eaLnBrk="1" latinLnBrk="0" hangingPunct="1">
-      <a:defRPr sz="1200" kern="1200">
-        <a:solidFill>
-          <a:schemeClr val="tx1"/>
-        </a:solidFill>
-        <a:latin typeface="+mn-lt"/>
-        <a:ea typeface="+mn-ea"/>
-        <a:cs typeface="+mn-cs"/>
-      </a:defRPr>
-    </a:lvl5pPr>
-    <a:lvl6pPr marL="2286000" algn="l" defTabSz="457200" rtl="0" eaLnBrk="1" latinLnBrk="0" hangingPunct="1">
-      <a:defRPr sz="1200" kern="1200">
-        <a:solidFill>
-          <a:schemeClr val="tx1"/>
-        </a:solidFill>
-        <a:latin typeface="+mn-lt"/>
-        <a:ea typeface="+mn-ea"/>
-        <a:cs typeface="+mn-cs"/>
-      </a:defRPr>
-    </a:lvl6pPr>
-    <a:lvl7pPr marL="2743200" algn="l" defTabSz="457200" rtl="0" eaLnBrk="1" latinLnBrk="0" hangingPunct="1">
-      <a:defRPr sz="1200" kern="1200">
-        <a:solidFill>
-          <a:schemeClr val="tx1"/>
-        </a:solidFill>
-        <a:latin typeface="+mn-lt"/>
-        <a:ea typeface="+mn-ea"/>
-        <a:cs typeface="+mn-cs"/>
-      </a:defRPr>
-    </a:lvl7pPr>
-    <a:lvl8pPr marL="3200400" algn="l" defTabSz="457200" rtl="0" eaLnBrk="1" latinLnBrk="0" hangingPunct="1">
-      <a:defRPr sz="1200" kern="1200">
-        <a:solidFill>
-          <a:schemeClr val="tx1"/>
-        </a:solidFill>
-        <a:latin typeface="+mn-lt"/>
-        <a:ea typeface="+mn-ea"/>
-        <a:cs typeface="+mn-cs"/>
-      </a:defRPr>
-    </a:lvl8pPr>
-    <a:lvl9pPr marL="3657600" algn="l" defTabSz="457200" rtl="0" eaLnBrk="1" latinLnBrk="0" hangingPunct="1">
-      <a:defRPr sz="1200" kern="1200">
-        <a:solidFill>
-          <a:schemeClr val="tx1"/>
-        </a:solidFill>
-        <a:latin typeface="+mn-lt"/>
-        <a:ea typeface="+mn-ea"/>
-        <a:cs typeface="+mn-cs"/>
-      </a:defRPr>
-    </a:lvl9pPr>
-  </p:notesStyle>
-</p:notesMaster>
-</file>
-
-<file path=ppt/notesSlides/notesSlide1.xml><?xml version="1.0" encoding="utf-8"?>
-<p:notes xmlns:a="http://schemas.openxmlformats.org/drawingml/2006/main" xmlns:p="http://schemas.openxmlformats.org/presentationml/2006/main" xmlns:r="http://schemas.openxmlformats.org/officeDocument/2006/relationships">
-  <p:cSld>
-    <p:spTree>
-      <p:nvGrpSpPr>
-        <p:cNvPr id="1" name=""/>
-        <p:cNvGrpSpPr/>
-        <p:nvPr/>
-      </p:nvGrpSpPr>
-      <p:grpSpPr>
-        <a:xfrm>
-          <a:off x="0" y="0"/>
-          <a:ext cx="0" cy="0"/>
-          <a:chOff x="0" y="0"/>
-          <a:chExt cx="0" cy="0"/>
-        </a:xfrm>
-      </p:grpSpPr>
-      <p:sp>
-        <p:nvSpPr>
-          <p:cNvPr id="2" name="Slide Image Placeholder 1"/>
-          <p:cNvSpPr>
-            <a:spLocks noGrp="1"/>
-          </p:cNvSpPr>
-          <p:nvPr>
-            <p:ph type="sldImg" idx="2"/>
-          </p:nvPr>
-        </p:nvSpPr>
-        <p:spPr/>
-      </p:sp>
-      <p:sp>
-        <p:nvSpPr>
-          <p:cNvPr id="3" name="Notes Placeholder 2"/>
-          <p:cNvSpPr>
-            <a:spLocks noGrp="1"/>
-          </p:cNvSpPr>
-          <p:nvPr>
-            <p:ph type="body" idx="3" sz="quarter"/>
-          </p:nvPr>
-        </p:nvSpPr>
-        <p:spPr/>
-        <p:txBody>
-          <a:bodyPr/>
-          <a:lstStyle/>
-          <a:p>
-            <a:r>
-              <a:t>Presenter: Talha. 30 seconds.</a:t>
-            </a:r>
-          </a:p>
-          <a:p>
-            <a:r>
-              <a:t>"We built an AI advisor for UTA CSE students with LangChain. It plans a degree semester by</a:t>
-            </a:r>
-          </a:p>
-          <a:p>
-            <a:r>
-              <a:t>semester, checks whether a course can be taken, answers questions from the catalog, and keeps a</a:t>
-            </a:r>
-          </a:p>
-          <a:p>
-            <a:r>
-              <a:t>full trace of how it reached every answer. Each of us owned one layer, listed here."</a:t>
-            </a:r>
-          </a:p>
-          <a:p>
-            <a:r>
-              <a:t>TODO before presenting: confirm full names for Miguel and Kyle.</a:t>
-            </a:r>
-          </a:p>
-        </p:txBody>
-      </p:sp>
-      <p:sp>
-        <p:nvSpPr>
-          <p:cNvPr id="4" name="Slide Number Placeholder 3"/>
-          <p:cNvSpPr>
-            <a:spLocks noGrp="1"/>
-          </p:cNvSpPr>
-          <p:nvPr>
-            <p:ph type="sldNum" idx="5" sz="quarter"/>
-          </p:nvPr>
-        </p:nvSpPr>
-        <p:spPr/>
-      </p:sp>
-    </p:spTree>
-  </p:cSld>
-  <p:clrMapOvr>
-    <a:masterClrMapping/>
-  </p:clrMapOvr>
-</p:notes>
-</file>
-
-<file path=ppt/notesSlides/notesSlide10.xml><?xml version="1.0" encoding="utf-8"?>
-<p:notes xmlns:a="http://schemas.openxmlformats.org/drawingml/2006/main" xmlns:p="http://schemas.openxmlformats.org/presentationml/2006/main" xmlns:r="http://schemas.openxmlformats.org/officeDocument/2006/relationships">
-  <p:cSld>
-    <p:spTree>
-      <p:nvGrpSpPr>
-        <p:cNvPr id="1" name=""/>
-        <p:cNvGrpSpPr/>
-        <p:nvPr/>
-      </p:nvGrpSpPr>
-      <p:grpSpPr>
-        <a:xfrm>
-          <a:off x="0" y="0"/>
-          <a:ext cx="0" cy="0"/>
-          <a:chOff x="0" y="0"/>
-          <a:chExt cx="0" cy="0"/>
-        </a:xfrm>
-      </p:grpSpPr>
-      <p:sp>
-        <p:nvSpPr>
-          <p:cNvPr id="2" name="Slide Image Placeholder 1"/>
-          <p:cNvSpPr>
-            <a:spLocks noGrp="1"/>
-          </p:cNvSpPr>
-          <p:nvPr>
-            <p:ph type="sldImg" idx="2"/>
-          </p:nvPr>
-        </p:nvSpPr>
-        <p:spPr/>
-      </p:sp>
-      <p:sp>
-        <p:nvSpPr>
-          <p:cNvPr id="3" name="Notes Placeholder 2"/>
-          <p:cNvSpPr>
-            <a:spLocks noGrp="1"/>
-          </p:cNvSpPr>
-          <p:nvPr>
-            <p:ph type="body" idx="3" sz="quarter"/>
-          </p:nvPr>
-        </p:nvSpPr>
-        <p:spPr/>
-        <p:txBody>
-          <a:bodyPr/>
-          <a:lstStyle/>
-          <a:p>
-            <a:r>
-              <a:t>Presenter: Kyle (router) + Miguel (retrieval).</a:t>
-            </a:r>
-          </a:p>
-          <a:p>
-            <a:r>
-              <a:t>This is a real turn from our trace log (screenshot later). Emphasise that routing is cheap:</a:t>
-            </a:r>
-          </a:p>
-          <a:p>
-            <a:r>
-              <a:t>keyword rules catch most phrasing so the LLM is only used where it adds value.</a:t>
-            </a:r>
-          </a:p>
-        </p:txBody>
-      </p:sp>
-      <p:sp>
-        <p:nvSpPr>
-          <p:cNvPr id="4" name="Slide Number Placeholder 3"/>
-          <p:cNvSpPr>
-            <a:spLocks noGrp="1"/>
-          </p:cNvSpPr>
-          <p:nvPr>
-            <p:ph type="sldNum" idx="5" sz="quarter"/>
-          </p:nvPr>
-        </p:nvSpPr>
-        <p:spPr/>
-      </p:sp>
-    </p:spTree>
-  </p:cSld>
-  <p:clrMapOvr>
-    <a:masterClrMapping/>
-  </p:clrMapOvr>
-</p:notes>
-</file>
-
-<file path=ppt/notesSlides/notesSlide11.xml><?xml version="1.0" encoding="utf-8"?>
-<p:notes xmlns:a="http://schemas.openxmlformats.org/drawingml/2006/main" xmlns:p="http://schemas.openxmlformats.org/presentationml/2006/main" xmlns:r="http://schemas.openxmlformats.org/officeDocument/2006/relationships">
-  <p:cSld>
-    <p:spTree>
-      <p:nvGrpSpPr>
-        <p:cNvPr id="1" name=""/>
-        <p:cNvGrpSpPr/>
-        <p:nvPr/>
-      </p:nvGrpSpPr>
-      <p:grpSpPr>
-        <a:xfrm>
-          <a:off x="0" y="0"/>
-          <a:ext cx="0" cy="0"/>
-          <a:chOff x="0" y="0"/>
-          <a:chExt cx="0" cy="0"/>
-        </a:xfrm>
-      </p:grpSpPr>
-      <p:sp>
-        <p:nvSpPr>
-          <p:cNvPr id="2" name="Slide Image Placeholder 1"/>
-          <p:cNvSpPr>
-            <a:spLocks noGrp="1"/>
-          </p:cNvSpPr>
-          <p:nvPr>
-            <p:ph type="sldImg" idx="2"/>
-          </p:nvPr>
-        </p:nvSpPr>
-        <p:spPr/>
-      </p:sp>
-      <p:sp>
-        <p:nvSpPr>
-          <p:cNvPr id="3" name="Notes Placeholder 2"/>
-          <p:cNvSpPr>
-            <a:spLocks noGrp="1"/>
-          </p:cNvSpPr>
-          <p:nvPr>
-            <p:ph type="body" idx="3" sz="quarter"/>
-          </p:nvPr>
-        </p:nvSpPr>
-        <p:spPr/>
-        <p:txBody>
-          <a:bodyPr/>
-          <a:lstStyle/>
-          <a:p>
-            <a:r>
-              <a:t>Presenter: Kyle. This is the template's 'how the relationships are implemented in code'.</a:t>
-            </a:r>
-          </a:p>
-        </p:txBody>
-      </p:sp>
-      <p:sp>
-        <p:nvSpPr>
-          <p:cNvPr id="4" name="Slide Number Placeholder 3"/>
-          <p:cNvSpPr>
-            <a:spLocks noGrp="1"/>
-          </p:cNvSpPr>
-          <p:nvPr>
-            <p:ph type="sldNum" idx="5" sz="quarter"/>
-          </p:nvPr>
-        </p:nvSpPr>
-        <p:spPr/>
-      </p:sp>
-    </p:spTree>
-  </p:cSld>
-  <p:clrMapOvr>
-    <a:masterClrMapping/>
-  </p:clrMapOvr>
-</p:notes>
-</file>
-
-<file path=ppt/notesSlides/notesSlide12.xml><?xml version="1.0" encoding="utf-8"?>
-<p:notes xmlns:a="http://schemas.openxmlformats.org/drawingml/2006/main" xmlns:p="http://schemas.openxmlformats.org/presentationml/2006/main" xmlns:r="http://schemas.openxmlformats.org/officeDocument/2006/relationships">
-  <p:cSld>
-    <p:spTree>
-      <p:nvGrpSpPr>
-        <p:cNvPr id="1" name=""/>
-        <p:cNvGrpSpPr/>
-        <p:nvPr/>
-      </p:nvGrpSpPr>
-      <p:grpSpPr>
-        <a:xfrm>
-          <a:off x="0" y="0"/>
-          <a:ext cx="0" cy="0"/>
-          <a:chOff x="0" y="0"/>
-          <a:chExt cx="0" cy="0"/>
-        </a:xfrm>
-      </p:grpSpPr>
-      <p:sp>
-        <p:nvSpPr>
-          <p:cNvPr id="2" name="Slide Image Placeholder 1"/>
-          <p:cNvSpPr>
-            <a:spLocks noGrp="1"/>
-          </p:cNvSpPr>
-          <p:nvPr>
-            <p:ph type="sldImg" idx="2"/>
-          </p:nvPr>
-        </p:nvSpPr>
-        <p:spPr/>
-      </p:sp>
-      <p:sp>
-        <p:nvSpPr>
-          <p:cNvPr id="3" name="Notes Placeholder 2"/>
-          <p:cNvSpPr>
-            <a:spLocks noGrp="1"/>
-          </p:cNvSpPr>
-          <p:nvPr>
-            <p:ph type="body" idx="3" sz="quarter"/>
-          </p:nvPr>
-        </p:nvSpPr>
-        <p:spPr/>
-        <p:txBody>
-          <a:bodyPr/>
-          <a:lstStyle/>
-          <a:p>
-            <a:r>
-              <a:t>Presenter: Jordan. Why it's needed: without structured requirement slots, nothing can</a:t>
-            </a:r>
-          </a:p>
-          <a:p>
-            <a:r>
-              <a:t>decide whether a course “counts” (check c) or what's left to graduate.</a:t>
-            </a:r>
-          </a:p>
-          <a:p>
-            <a:r>
-              <a:t>Explain what the segment does (left) and why the system needs it (right).</a:t>
-            </a:r>
-          </a:p>
-        </p:txBody>
-      </p:sp>
-      <p:sp>
-        <p:nvSpPr>
-          <p:cNvPr id="4" name="Slide Number Placeholder 3"/>
-          <p:cNvSpPr>
-            <a:spLocks noGrp="1"/>
-          </p:cNvSpPr>
-          <p:nvPr>
-            <p:ph type="sldNum" idx="5" sz="quarter"/>
-          </p:nvPr>
-        </p:nvSpPr>
-        <p:spPr/>
-      </p:sp>
-    </p:spTree>
-  </p:cSld>
-  <p:clrMapOvr>
-    <a:masterClrMapping/>
-  </p:clrMapOvr>
-</p:notes>
-</file>
-
-<file path=ppt/notesSlides/notesSlide13.xml><?xml version="1.0" encoding="utf-8"?>
-<p:notes xmlns:a="http://schemas.openxmlformats.org/drawingml/2006/main" xmlns:p="http://schemas.openxmlformats.org/presentationml/2006/main" xmlns:r="http://schemas.openxmlformats.org/officeDocument/2006/relationships">
-  <p:cSld>
-    <p:spTree>
-      <p:nvGrpSpPr>
-        <p:cNvPr id="1" name=""/>
-        <p:cNvGrpSpPr/>
-        <p:nvPr/>
-      </p:nvGrpSpPr>
-      <p:grpSpPr>
-        <a:xfrm>
-          <a:off x="0" y="0"/>
-          <a:ext cx="0" cy="0"/>
-          <a:chOff x="0" y="0"/>
-          <a:chExt cx="0" cy="0"/>
-        </a:xfrm>
-      </p:grpSpPr>
-      <p:sp>
-        <p:nvSpPr>
-          <p:cNvPr id="2" name="Slide Image Placeholder 1"/>
-          <p:cNvSpPr>
-            <a:spLocks noGrp="1"/>
-          </p:cNvSpPr>
-          <p:nvPr>
-            <p:ph type="sldImg" idx="2"/>
-          </p:nvPr>
-        </p:nvSpPr>
-        <p:spPr/>
-      </p:sp>
-      <p:sp>
-        <p:nvSpPr>
-          <p:cNvPr id="3" name="Notes Placeholder 2"/>
-          <p:cNvSpPr>
-            <a:spLocks noGrp="1"/>
-          </p:cNvSpPr>
-          <p:nvPr>
-            <p:ph type="body" idx="3" sz="quarter"/>
-          </p:nvPr>
-        </p:nvSpPr>
-        <p:spPr/>
-        <p:txBody>
-          <a:bodyPr/>
-          <a:lstStyle/>
-          <a:p>
-            <a:r>
-              <a:t>Presenter: Kyle.</a:t>
-            </a:r>
-          </a:p>
-          <a:p>
-            <a:r>
-              <a:t>Explain what the segment does (left) and why the system needs it (right).</a:t>
-            </a:r>
-          </a:p>
-        </p:txBody>
-      </p:sp>
-      <p:sp>
-        <p:nvSpPr>
-          <p:cNvPr id="4" name="Slide Number Placeholder 3"/>
-          <p:cNvSpPr>
-            <a:spLocks noGrp="1"/>
-          </p:cNvSpPr>
-          <p:nvPr>
-            <p:ph type="sldNum" idx="5" sz="quarter"/>
-          </p:nvPr>
-        </p:nvSpPr>
-        <p:spPr/>
-      </p:sp>
-    </p:spTree>
-  </p:cSld>
-  <p:clrMapOvr>
-    <a:masterClrMapping/>
-  </p:clrMapOvr>
-</p:notes>
-</file>
-
-<file path=ppt/notesSlides/notesSlide14.xml><?xml version="1.0" encoding="utf-8"?>
-<p:notes xmlns:a="http://schemas.openxmlformats.org/drawingml/2006/main" xmlns:p="http://schemas.openxmlformats.org/presentationml/2006/main" xmlns:r="http://schemas.openxmlformats.org/officeDocument/2006/relationships">
-  <p:cSld>
-    <p:spTree>
-      <p:nvGrpSpPr>
-        <p:cNvPr id="1" name=""/>
-        <p:cNvGrpSpPr/>
-        <p:nvPr/>
-      </p:nvGrpSpPr>
-      <p:grpSpPr>
-        <a:xfrm>
-          <a:off x="0" y="0"/>
-          <a:ext cx="0" cy="0"/>
-          <a:chOff x="0" y="0"/>
-          <a:chExt cx="0" cy="0"/>
-        </a:xfrm>
-      </p:grpSpPr>
-      <p:sp>
-        <p:nvSpPr>
-          <p:cNvPr id="2" name="Slide Image Placeholder 1"/>
-          <p:cNvSpPr>
-            <a:spLocks noGrp="1"/>
-          </p:cNvSpPr>
-          <p:nvPr>
-            <p:ph type="sldImg" idx="2"/>
-          </p:nvPr>
-        </p:nvSpPr>
-        <p:spPr/>
-      </p:sp>
-      <p:sp>
-        <p:nvSpPr>
-          <p:cNvPr id="3" name="Notes Placeholder 2"/>
-          <p:cNvSpPr>
-            <a:spLocks noGrp="1"/>
-          </p:cNvSpPr>
-          <p:nvPr>
-            <p:ph type="body" idx="3" sz="quarter"/>
-          </p:nvPr>
-        </p:nvSpPr>
-        <p:spPr/>
-        <p:txBody>
-          <a:bodyPr/>
-          <a:lstStyle/>
-          <a:p>
-            <a:r>
-              <a:t>Presenter: Kyle.</a:t>
-            </a:r>
-          </a:p>
-          <a:p>
-            <a:r>
-              <a:t>Explain what the segment does (left) and why the system needs it (right).</a:t>
-            </a:r>
-          </a:p>
-        </p:txBody>
-      </p:sp>
-      <p:sp>
-        <p:nvSpPr>
-          <p:cNvPr id="4" name="Slide Number Placeholder 3"/>
-          <p:cNvSpPr>
-            <a:spLocks noGrp="1"/>
-          </p:cNvSpPr>
-          <p:nvPr>
-            <p:ph type="sldNum" idx="5" sz="quarter"/>
-          </p:nvPr>
-        </p:nvSpPr>
-        <p:spPr/>
-      </p:sp>
-    </p:spTree>
-  </p:cSld>
-  <p:clrMapOvr>
-    <a:masterClrMapping/>
-  </p:clrMapOvr>
-</p:notes>
-</file>
-
-<file path=ppt/notesSlides/notesSlide15.xml><?xml version="1.0" encoding="utf-8"?>
-<p:notes xmlns:a="http://schemas.openxmlformats.org/drawingml/2006/main" xmlns:p="http://schemas.openxmlformats.org/presentationml/2006/main" xmlns:r="http://schemas.openxmlformats.org/officeDocument/2006/relationships">
-  <p:cSld>
-    <p:spTree>
-      <p:nvGrpSpPr>
-        <p:cNvPr id="1" name=""/>
-        <p:cNvGrpSpPr/>
-        <p:nvPr/>
-      </p:nvGrpSpPr>
-      <p:grpSpPr>
-        <a:xfrm>
-          <a:off x="0" y="0"/>
-          <a:ext cx="0" cy="0"/>
-          <a:chOff x="0" y="0"/>
-          <a:chExt cx="0" cy="0"/>
-        </a:xfrm>
-      </p:grpSpPr>
-      <p:sp>
-        <p:nvSpPr>
-          <p:cNvPr id="2" name="Slide Image Placeholder 1"/>
-          <p:cNvSpPr>
-            <a:spLocks noGrp="1"/>
-          </p:cNvSpPr>
-          <p:nvPr>
-            <p:ph type="sldImg" idx="2"/>
-          </p:nvPr>
-        </p:nvSpPr>
-        <p:spPr/>
-      </p:sp>
-      <p:sp>
-        <p:nvSpPr>
-          <p:cNvPr id="3" name="Notes Placeholder 2"/>
-          <p:cNvSpPr>
-            <a:spLocks noGrp="1"/>
-          </p:cNvSpPr>
-          <p:nvPr>
-            <p:ph type="body" idx="3" sz="quarter"/>
-          </p:nvPr>
-        </p:nvSpPr>
-        <p:spPr/>
-        <p:txBody>
-          <a:bodyPr/>
-          <a:lstStyle/>
-          <a:p>
-            <a:r>
-              <a:t>Presenter: Miguel.</a:t>
-            </a:r>
-          </a:p>
-          <a:p>
-            <a:r>
-              <a:t>Explain what the segment does (left) and why the system needs it (right).</a:t>
-            </a:r>
-          </a:p>
-        </p:txBody>
-      </p:sp>
-      <p:sp>
-        <p:nvSpPr>
-          <p:cNvPr id="4" name="Slide Number Placeholder 3"/>
-          <p:cNvSpPr>
-            <a:spLocks noGrp="1"/>
-          </p:cNvSpPr>
-          <p:nvPr>
-            <p:ph type="sldNum" idx="5" sz="quarter"/>
-          </p:nvPr>
-        </p:nvSpPr>
-        <p:spPr/>
-      </p:sp>
-    </p:spTree>
-  </p:cSld>
-  <p:clrMapOvr>
-    <a:masterClrMapping/>
-  </p:clrMapOvr>
-</p:notes>
-</file>
-
-<file path=ppt/notesSlides/notesSlide16.xml><?xml version="1.0" encoding="utf-8"?>
-<p:notes xmlns:a="http://schemas.openxmlformats.org/drawingml/2006/main" xmlns:p="http://schemas.openxmlformats.org/presentationml/2006/main" xmlns:r="http://schemas.openxmlformats.org/officeDocument/2006/relationships">
-  <p:cSld>
-    <p:spTree>
-      <p:nvGrpSpPr>
-        <p:cNvPr id="1" name=""/>
-        <p:cNvGrpSpPr/>
-        <p:nvPr/>
-      </p:nvGrpSpPr>
-      <p:grpSpPr>
-        <a:xfrm>
-          <a:off x="0" y="0"/>
-          <a:ext cx="0" cy="0"/>
-          <a:chOff x="0" y="0"/>
-          <a:chExt cx="0" cy="0"/>
-        </a:xfrm>
-      </p:grpSpPr>
-      <p:sp>
-        <p:nvSpPr>
-          <p:cNvPr id="2" name="Slide Image Placeholder 1"/>
-          <p:cNvSpPr>
-            <a:spLocks noGrp="1"/>
-          </p:cNvSpPr>
-          <p:nvPr>
-            <p:ph type="sldImg" idx="2"/>
-          </p:nvPr>
-        </p:nvSpPr>
-        <p:spPr/>
-      </p:sp>
-      <p:sp>
-        <p:nvSpPr>
-          <p:cNvPr id="3" name="Notes Placeholder 2"/>
-          <p:cNvSpPr>
-            <a:spLocks noGrp="1"/>
-          </p:cNvSpPr>
-          <p:nvPr>
-            <p:ph type="body" idx="3" sz="quarter"/>
-          </p:nvPr>
-        </p:nvSpPr>
-        <p:spPr/>
-        <p:txBody>
-          <a:bodyPr/>
-          <a:lstStyle/>
-          <a:p>
-            <a:r>
-              <a:t>Presenter: Loc.</a:t>
-            </a:r>
-          </a:p>
-          <a:p>
-            <a:r>
-              <a:t>Explain what the segment does (left) and why the system needs it (right).</a:t>
-            </a:r>
-          </a:p>
-        </p:txBody>
-      </p:sp>
-      <p:sp>
-        <p:nvSpPr>
-          <p:cNvPr id="4" name="Slide Number Placeholder 3"/>
-          <p:cNvSpPr>
-            <a:spLocks noGrp="1"/>
-          </p:cNvSpPr>
-          <p:nvPr>
-            <p:ph type="sldNum" idx="5" sz="quarter"/>
-          </p:nvPr>
-        </p:nvSpPr>
-        <p:spPr/>
-      </p:sp>
-    </p:spTree>
-  </p:cSld>
-  <p:clrMapOvr>
-    <a:masterClrMapping/>
-  </p:clrMapOvr>
-</p:notes>
-</file>
-
-<file path=ppt/notesSlides/notesSlide17.xml><?xml version="1.0" encoding="utf-8"?>
-<p:notes xmlns:a="http://schemas.openxmlformats.org/drawingml/2006/main" xmlns:p="http://schemas.openxmlformats.org/presentationml/2006/main" xmlns:r="http://schemas.openxmlformats.org/officeDocument/2006/relationships">
-  <p:cSld>
-    <p:spTree>
-      <p:nvGrpSpPr>
-        <p:cNvPr id="1" name=""/>
-        <p:cNvGrpSpPr/>
-        <p:nvPr/>
-      </p:nvGrpSpPr>
-      <p:grpSpPr>
-        <a:xfrm>
-          <a:off x="0" y="0"/>
-          <a:ext cx="0" cy="0"/>
-          <a:chOff x="0" y="0"/>
-          <a:chExt cx="0" cy="0"/>
-        </a:xfrm>
-      </p:grpSpPr>
-      <p:sp>
-        <p:nvSpPr>
-          <p:cNvPr id="2" name="Slide Image Placeholder 1"/>
-          <p:cNvSpPr>
-            <a:spLocks noGrp="1"/>
-          </p:cNvSpPr>
-          <p:nvPr>
-            <p:ph type="sldImg" idx="2"/>
-          </p:nvPr>
-        </p:nvSpPr>
-        <p:spPr/>
-      </p:sp>
-      <p:sp>
-        <p:nvSpPr>
-          <p:cNvPr id="3" name="Notes Placeholder 2"/>
-          <p:cNvSpPr>
-            <a:spLocks noGrp="1"/>
-          </p:cNvSpPr>
-          <p:nvPr>
-            <p:ph type="body" idx="3" sz="quarter"/>
-          </p:nvPr>
-        </p:nvSpPr>
-        <p:spPr/>
-        <p:txBody>
-          <a:bodyPr/>
-          <a:lstStyle/>
-          <a:p>
-            <a:r>
-              <a:t>Presenter: Talha.</a:t>
-            </a:r>
-          </a:p>
-          <a:p>
-            <a:r>
-              <a:t>Explain what the segment does (left) and why the system needs it (right).</a:t>
-            </a:r>
-          </a:p>
-        </p:txBody>
-      </p:sp>
-      <p:sp>
-        <p:nvSpPr>
-          <p:cNvPr id="4" name="Slide Number Placeholder 3"/>
-          <p:cNvSpPr>
-            <a:spLocks noGrp="1"/>
-          </p:cNvSpPr>
-          <p:nvPr>
-            <p:ph type="sldNum" idx="5" sz="quarter"/>
-          </p:nvPr>
-        </p:nvSpPr>
-        <p:spPr/>
-      </p:sp>
-    </p:spTree>
-  </p:cSld>
-  <p:clrMapOvr>
-    <a:masterClrMapping/>
-  </p:clrMapOvr>
-</p:notes>
-</file>
-
-<file path=ppt/notesSlides/notesSlide18.xml><?xml version="1.0" encoding="utf-8"?>
-<p:notes xmlns:a="http://schemas.openxmlformats.org/drawingml/2006/main" xmlns:p="http://schemas.openxmlformats.org/presentationml/2006/main" xmlns:r="http://schemas.openxmlformats.org/officeDocument/2006/relationships">
-  <p:cSld>
-    <p:spTree>
-      <p:nvGrpSpPr>
-        <p:cNvPr id="1" name=""/>
-        <p:cNvGrpSpPr/>
-        <p:nvPr/>
-      </p:nvGrpSpPr>
-      <p:grpSpPr>
-        <a:xfrm>
-          <a:off x="0" y="0"/>
-          <a:ext cx="0" cy="0"/>
-          <a:chOff x="0" y="0"/>
-          <a:chExt cx="0" cy="0"/>
-        </a:xfrm>
-      </p:grpSpPr>
-      <p:sp>
-        <p:nvSpPr>
-          <p:cNvPr id="2" name="Slide Image Placeholder 1"/>
-          <p:cNvSpPr>
-            <a:spLocks noGrp="1"/>
-          </p:cNvSpPr>
-          <p:nvPr>
-            <p:ph type="sldImg" idx="2"/>
-          </p:nvPr>
-        </p:nvSpPr>
-        <p:spPr/>
-      </p:sp>
-      <p:sp>
-        <p:nvSpPr>
-          <p:cNvPr id="3" name="Notes Placeholder 2"/>
-          <p:cNvSpPr>
-            <a:spLocks noGrp="1"/>
-          </p:cNvSpPr>
-          <p:nvPr>
-            <p:ph type="body" idx="3" sz="quarter"/>
-          </p:nvPr>
-        </p:nvSpPr>
-        <p:spPr/>
-        <p:txBody>
-          <a:bodyPr/>
-          <a:lstStyle/>
-          <a:p>
-            <a:r>
-              <a:t>Input: Pick a student</a:t>
-            </a:r>
-          </a:p>
-          <a:p>
-            <a:r>
-              <a:t>Output: Credits done, in progress, and per-area requirement rings from SQLite</a:t>
-            </a:r>
-          </a:p>
-          <a:p>
-            <a:r>
-              <a:t>What it means: Sam has 32 of 123 credits; blue is this fall’s 4 classes. The certificate ring is empty: still to plan.</a:t>
-            </a:r>
-          </a:p>
-        </p:txBody>
-      </p:sp>
-      <p:sp>
-        <p:nvSpPr>
-          <p:cNvPr id="4" name="Slide Number Placeholder 3"/>
-          <p:cNvSpPr>
-            <a:spLocks noGrp="1"/>
-          </p:cNvSpPr>
-          <p:nvPr>
-            <p:ph type="sldNum" idx="5" sz="quarter"/>
-          </p:nvPr>
-        </p:nvSpPr>
-        <p:spPr/>
-      </p:sp>
-    </p:spTree>
-  </p:cSld>
-  <p:clrMapOvr>
-    <a:masterClrMapping/>
-  </p:clrMapOvr>
-</p:notes>
-</file>
-
-<file path=ppt/notesSlides/notesSlide19.xml><?xml version="1.0" encoding="utf-8"?>
-<p:notes xmlns:a="http://schemas.openxmlformats.org/drawingml/2006/main" xmlns:p="http://schemas.openxmlformats.org/presentationml/2006/main" xmlns:r="http://schemas.openxmlformats.org/officeDocument/2006/relationships">
-  <p:cSld>
-    <p:spTree>
-      <p:nvGrpSpPr>
-        <p:cNvPr id="1" name=""/>
-        <p:cNvGrpSpPr/>
-        <p:nvPr/>
-      </p:nvGrpSpPr>
-      <p:grpSpPr>
-        <a:xfrm>
-          <a:off x="0" y="0"/>
-          <a:ext cx="0" cy="0"/>
-          <a:chOff x="0" y="0"/>
-          <a:chExt cx="0" cy="0"/>
-        </a:xfrm>
-      </p:grpSpPr>
-      <p:sp>
-        <p:nvSpPr>
-          <p:cNvPr id="2" name="Slide Image Placeholder 1"/>
-          <p:cNvSpPr>
-            <a:spLocks noGrp="1"/>
-          </p:cNvSpPr>
-          <p:nvPr>
-            <p:ph type="sldImg" idx="2"/>
-          </p:nvPr>
-        </p:nvSpPr>
-        <p:spPr/>
-      </p:sp>
-      <p:sp>
-        <p:nvSpPr>
-          <p:cNvPr id="3" name="Notes Placeholder 2"/>
-          <p:cNvSpPr>
-            <a:spLocks noGrp="1"/>
-          </p:cNvSpPr>
-          <p:nvPr>
-            <p:ph type="body" idx="3" sz="quarter"/>
-          </p:nvPr>
-        </p:nvSpPr>
-        <p:spPr/>
-        <p:txBody>
-          <a:bodyPr/>
-          <a:lstStyle/>
-          <a:p>
-            <a:r>
-              <a:t>Input: Plan → Build plan (auto load, no summer) → Years</a:t>
-            </a:r>
-          </a:p>
-          <a:p>
-            <a:r>
-              <a:t>Output: Completed terms (green), then planned semesters (blue), year by year</a:t>
-            </a:r>
-          </a:p>
-          <a:p>
-            <a:r>
-              <a:t>What it means: Graduation in Spring 2029, in prerequisite order within the 15-credit cap; terms after Summer 2027 are projected.</a:t>
-            </a:r>
-          </a:p>
-        </p:txBody>
-      </p:sp>
-      <p:sp>
-        <p:nvSpPr>
-          <p:cNvPr id="4" name="Slide Number Placeholder 3"/>
-          <p:cNvSpPr>
-            <a:spLocks noGrp="1"/>
-          </p:cNvSpPr>
-          <p:nvPr>
-            <p:ph type="sldNum" idx="5" sz="quarter"/>
-          </p:nvPr>
-        </p:nvSpPr>
-        <p:spPr/>
-      </p:sp>
-    </p:spTree>
-  </p:cSld>
-  <p:clrMapOvr>
-    <a:masterClrMapping/>
-  </p:clrMapOvr>
-</p:notes>
-</file>
-
-<file path=ppt/notesSlides/notesSlide2.xml><?xml version="1.0" encoding="utf-8"?>
-<p:notes xmlns:a="http://schemas.openxmlformats.org/drawingml/2006/main" xmlns:p="http://schemas.openxmlformats.org/presentationml/2006/main" xmlns:r="http://schemas.openxmlformats.org/officeDocument/2006/relationships">
-  <p:cSld>
-    <p:spTree>
-      <p:nvGrpSpPr>
-        <p:cNvPr id="1" name=""/>
-        <p:cNvGrpSpPr/>
-        <p:nvPr/>
-      </p:nvGrpSpPr>
-      <p:grpSpPr>
-        <a:xfrm>
-          <a:off x="0" y="0"/>
-          <a:ext cx="0" cy="0"/>
-          <a:chOff x="0" y="0"/>
-          <a:chExt cx="0" cy="0"/>
-        </a:xfrm>
-      </p:grpSpPr>
-      <p:sp>
-        <p:nvSpPr>
-          <p:cNvPr id="2" name="Slide Image Placeholder 1"/>
-          <p:cNvSpPr>
-            <a:spLocks noGrp="1"/>
-          </p:cNvSpPr>
-          <p:nvPr>
-            <p:ph type="sldImg" idx="2"/>
-          </p:nvPr>
-        </p:nvSpPr>
-        <p:spPr/>
-      </p:sp>
-      <p:sp>
-        <p:nvSpPr>
-          <p:cNvPr id="3" name="Notes Placeholder 2"/>
-          <p:cNvSpPr>
-            <a:spLocks noGrp="1"/>
-          </p:cNvSpPr>
-          <p:nvPr>
-            <p:ph type="body" idx="3" sz="quarter"/>
-          </p:nvPr>
-        </p:nvSpPr>
-        <p:spPr/>
-        <p:txBody>
-          <a:bodyPr/>
-          <a:lstStyle/>
-          <a:p>
-            <a:r>
-              <a:t>Presenter: Talha. 20 seconds: the order of the talk, which follows the course template.</a:t>
-            </a:r>
-          </a:p>
-        </p:txBody>
-      </p:sp>
-      <p:sp>
-        <p:nvSpPr>
-          <p:cNvPr id="4" name="Slide Number Placeholder 3"/>
-          <p:cNvSpPr>
-            <a:spLocks noGrp="1"/>
-          </p:cNvSpPr>
-          <p:nvPr>
-            <p:ph type="sldNum" idx="5" sz="quarter"/>
-          </p:nvPr>
-        </p:nvSpPr>
-        <p:spPr/>
-      </p:sp>
-    </p:spTree>
-  </p:cSld>
-  <p:clrMapOvr>
-    <a:masterClrMapping/>
-  </p:clrMapOvr>
-</p:notes>
-</file>
-
-<file path=ppt/notesSlides/notesSlide20.xml><?xml version="1.0" encoding="utf-8"?>
-<p:notes xmlns:a="http://schemas.openxmlformats.org/drawingml/2006/main" xmlns:p="http://schemas.openxmlformats.org/presentationml/2006/main" xmlns:r="http://schemas.openxmlformats.org/officeDocument/2006/relationships">
-  <p:cSld>
-    <p:spTree>
-      <p:nvGrpSpPr>
-        <p:cNvPr id="1" name=""/>
-        <p:cNvGrpSpPr/>
-        <p:nvPr/>
-      </p:nvGrpSpPr>
-      <p:grpSpPr>
-        <a:xfrm>
-          <a:off x="0" y="0"/>
-          <a:ext cx="0" cy="0"/>
-          <a:chOff x="0" y="0"/>
-          <a:chExt cx="0" cy="0"/>
-        </a:xfrm>
-      </p:grpSpPr>
-      <p:sp>
-        <p:nvSpPr>
-          <p:cNvPr id="2" name="Slide Image Placeholder 1"/>
-          <p:cNvSpPr>
-            <a:spLocks noGrp="1"/>
-          </p:cNvSpPr>
-          <p:nvPr>
-            <p:ph type="sldImg" idx="2"/>
-          </p:nvPr>
-        </p:nvSpPr>
-        <p:spPr/>
-      </p:sp>
-      <p:sp>
-        <p:nvSpPr>
-          <p:cNvPr id="3" name="Notes Placeholder 2"/>
-          <p:cNvSpPr>
-            <a:spLocks noGrp="1"/>
-          </p:cNvSpPr>
-          <p:nvPr>
-            <p:ph type="body" idx="3" sz="quarter"/>
-          </p:nvPr>
-        </p:nvSpPr>
-        <p:spPr/>
-        <p:txBody>
-          <a:bodyPr/>
-          <a:lstStyle/>
-          <a:p>
-            <a:r>
-              <a:t>Input: Check a course: CSE 3320, Spring 2027</a:t>
-            </a:r>
-          </a:p>
-          <a:p>
-            <a:r>
-              <a:t>Output: Checks (a)–(f), each with pass/fail and the reason</a:t>
-            </a:r>
-          </a:p>
-          <a:p>
-            <a:r>
-              <a:t>What it means: All six pass for the course the planner chose for Spring 2027; any failure blocks a recommendation and says what to fix.</a:t>
-            </a:r>
-          </a:p>
-        </p:txBody>
-      </p:sp>
-      <p:sp>
-        <p:nvSpPr>
-          <p:cNvPr id="4" name="Slide Number Placeholder 3"/>
-          <p:cNvSpPr>
-            <a:spLocks noGrp="1"/>
-          </p:cNvSpPr>
-          <p:nvPr>
-            <p:ph type="sldNum" idx="5" sz="quarter"/>
-          </p:nvPr>
-        </p:nvSpPr>
-        <p:spPr/>
-      </p:sp>
-    </p:spTree>
-  </p:cSld>
-  <p:clrMapOvr>
-    <a:masterClrMapping/>
-  </p:clrMapOvr>
-</p:notes>
-</file>
-
-<file path=ppt/notesSlides/notesSlide21.xml><?xml version="1.0" encoding="utf-8"?>
-<p:notes xmlns:a="http://schemas.openxmlformats.org/drawingml/2006/main" xmlns:p="http://schemas.openxmlformats.org/presentationml/2006/main" xmlns:r="http://schemas.openxmlformats.org/officeDocument/2006/relationships">
-  <p:cSld>
-    <p:spTree>
-      <p:nvGrpSpPr>
-        <p:cNvPr id="1" name=""/>
-        <p:cNvGrpSpPr/>
-        <p:nvPr/>
-      </p:nvGrpSpPr>
-      <p:grpSpPr>
-        <a:xfrm>
-          <a:off x="0" y="0"/>
-          <a:ext cx="0" cy="0"/>
-          <a:chOff x="0" y="0"/>
-          <a:chExt cx="0" cy="0"/>
-        </a:xfrm>
-      </p:grpSpPr>
-      <p:sp>
-        <p:nvSpPr>
-          <p:cNvPr id="2" name="Slide Image Placeholder 1"/>
-          <p:cNvSpPr>
-            <a:spLocks noGrp="1"/>
-          </p:cNvSpPr>
-          <p:nvPr>
-            <p:ph type="sldImg" idx="2"/>
-          </p:nvPr>
-        </p:nvSpPr>
-        <p:spPr/>
-      </p:sp>
-      <p:sp>
-        <p:nvSpPr>
-          <p:cNvPr id="3" name="Notes Placeholder 2"/>
-          <p:cNvSpPr>
-            <a:spLocks noGrp="1"/>
-          </p:cNvSpPr>
-          <p:nvPr>
-            <p:ph type="body" idx="3" sz="quarter"/>
-          </p:nvPr>
-        </p:nvSpPr>
-        <p:spPr/>
-        <p:txBody>
-          <a:bodyPr/>
-          <a:lstStyle/>
-          <a:p>
-            <a:r>
-              <a:t>Input: Plan → Add a course: BIOL 1441, Fall 2026</a:t>
-            </a:r>
-          </a:p>
-          <a:p>
-            <a:r>
-              <a:t>Output: Three checks fail: it doesn’t count toward the degree, 17 of 15 semester credits, 124 of 123 degree credits. Add stays disabled</a:t>
-            </a:r>
-          </a:p>
-          <a:p>
-            <a:r>
-              <a:t>What it means: Constraints are enforced, not just reported: the advisor won’t add a course that breaks one.</a:t>
-            </a:r>
-          </a:p>
-        </p:txBody>
-      </p:sp>
-      <p:sp>
-        <p:nvSpPr>
-          <p:cNvPr id="4" name="Slide Number Placeholder 3"/>
-          <p:cNvSpPr>
-            <a:spLocks noGrp="1"/>
-          </p:cNvSpPr>
-          <p:nvPr>
-            <p:ph type="sldNum" idx="5" sz="quarter"/>
-          </p:nvPr>
-        </p:nvSpPr>
-        <p:spPr/>
-      </p:sp>
-    </p:spTree>
-  </p:cSld>
-  <p:clrMapOvr>
-    <a:masterClrMapping/>
-  </p:clrMapOvr>
-</p:notes>
-</file>
-
-<file path=ppt/notesSlides/notesSlide22.xml><?xml version="1.0" encoding="utf-8"?>
-<p:notes xmlns:a="http://schemas.openxmlformats.org/drawingml/2006/main" xmlns:p="http://schemas.openxmlformats.org/presentationml/2006/main" xmlns:r="http://schemas.openxmlformats.org/officeDocument/2006/relationships">
-  <p:cSld>
-    <p:spTree>
-      <p:nvGrpSpPr>
-        <p:cNvPr id="1" name=""/>
-        <p:cNvGrpSpPr/>
-        <p:nvPr/>
-      </p:nvGrpSpPr>
-      <p:grpSpPr>
-        <a:xfrm>
-          <a:off x="0" y="0"/>
-          <a:ext cx="0" cy="0"/>
-          <a:chOff x="0" y="0"/>
-          <a:chExt cx="0" cy="0"/>
-        </a:xfrm>
-      </p:grpSpPr>
-      <p:sp>
-        <p:nvSpPr>
-          <p:cNvPr id="2" name="Slide Image Placeholder 1"/>
-          <p:cNvSpPr>
-            <a:spLocks noGrp="1"/>
-          </p:cNvSpPr>
-          <p:nvPr>
-            <p:ph type="sldImg" idx="2"/>
-          </p:nvPr>
-        </p:nvSpPr>
-        <p:spPr/>
-      </p:sp>
-      <p:sp>
-        <p:nvSpPr>
-          <p:cNvPr id="3" name="Notes Placeholder 2"/>
-          <p:cNvSpPr>
-            <a:spLocks noGrp="1"/>
-          </p:cNvSpPr>
-          <p:nvPr>
-            <p:ph type="body" idx="3" sz="quarter"/>
-          </p:nvPr>
-        </p:nvSpPr>
-        <p:spPr/>
-        <p:txBody>
-          <a:bodyPr/>
-          <a:lstStyle/>
-          <a:p>
-            <a:r>
-              <a:t>Input: “Prerequisites for CSE 3310?” then “Which courses cover machine learning?”</a:t>
-            </a:r>
-          </a:p>
-          <a:p>
-            <a:r>
-              <a:t>Output: SQL answer in milliseconds; RAG answer grounded in the catalog</a:t>
-            </a:r>
-          </a:p>
-          <a:p>
-            <a:r>
-              <a:t>What it means: Same chat, two paths: the router sent the first to SQL and the second to Chroma + the LLM.</a:t>
-            </a:r>
-          </a:p>
-        </p:txBody>
-      </p:sp>
-      <p:sp>
-        <p:nvSpPr>
-          <p:cNvPr id="4" name="Slide Number Placeholder 3"/>
-          <p:cNvSpPr>
-            <a:spLocks noGrp="1"/>
-          </p:cNvSpPr>
-          <p:nvPr>
-            <p:ph type="sldNum" idx="5" sz="quarter"/>
-          </p:nvPr>
-        </p:nvSpPr>
-        <p:spPr/>
-      </p:sp>
-    </p:spTree>
-  </p:cSld>
-  <p:clrMapOvr>
-    <a:masterClrMapping/>
-  </p:clrMapOvr>
-</p:notes>
-</file>
-
-<file path=ppt/notesSlides/notesSlide23.xml><?xml version="1.0" encoding="utf-8"?>
-<p:notes xmlns:a="http://schemas.openxmlformats.org/drawingml/2006/main" xmlns:p="http://schemas.openxmlformats.org/presentationml/2006/main" xmlns:r="http://schemas.openxmlformats.org/officeDocument/2006/relationships">
-  <p:cSld>
-    <p:spTree>
-      <p:nvGrpSpPr>
-        <p:cNvPr id="1" name=""/>
-        <p:cNvGrpSpPr/>
-        <p:nvPr/>
-      </p:nvGrpSpPr>
-      <p:grpSpPr>
-        <a:xfrm>
-          <a:off x="0" y="0"/>
-          <a:ext cx="0" cy="0"/>
-          <a:chOff x="0" y="0"/>
-          <a:chExt cx="0" cy="0"/>
-        </a:xfrm>
-      </p:grpSpPr>
-      <p:sp>
-        <p:nvSpPr>
-          <p:cNvPr id="2" name="Slide Image Placeholder 1"/>
-          <p:cNvSpPr>
-            <a:spLocks noGrp="1"/>
-          </p:cNvSpPr>
-          <p:nvPr>
-            <p:ph type="sldImg" idx="2"/>
-          </p:nvPr>
-        </p:nvSpPr>
-        <p:spPr/>
-      </p:sp>
-      <p:sp>
-        <p:nvSpPr>
-          <p:cNvPr id="3" name="Notes Placeholder 2"/>
-          <p:cNvSpPr>
-            <a:spLocks noGrp="1"/>
-          </p:cNvSpPr>
-          <p:nvPr>
-            <p:ph type="body" idx="3" sz="quarter"/>
-          </p:nvPr>
-        </p:nvSpPr>
-        <p:spPr/>
-        <p:txBody>
-          <a:bodyPr/>
-          <a:lstStyle/>
-          <a:p>
-            <a:r>
-              <a:t>Input: “Generate my degree plan”, then “What about only 3 classes next semester?”</a:t>
-            </a:r>
-          </a:p>
-          <a:p>
-            <a:r>
-              <a:t>Output: A new plan with 3 classes in Spring 2027</a:t>
-            </a:r>
-          </a:p>
-          <a:p>
-            <a:r>
-              <a:t>What it means: The follow-up has no subject of its own; the history passed into the turn makes it resolvable.</a:t>
-            </a:r>
-          </a:p>
-        </p:txBody>
-      </p:sp>
-      <p:sp>
-        <p:nvSpPr>
-          <p:cNvPr id="4" name="Slide Number Placeholder 3"/>
-          <p:cNvSpPr>
-            <a:spLocks noGrp="1"/>
-          </p:cNvSpPr>
-          <p:nvPr>
-            <p:ph type="sldNum" idx="5" sz="quarter"/>
-          </p:nvPr>
-        </p:nvSpPr>
-        <p:spPr/>
-      </p:sp>
-    </p:spTree>
-  </p:cSld>
-  <p:clrMapOvr>
-    <a:masterClrMapping/>
-  </p:clrMapOvr>
-</p:notes>
-</file>
-
-<file path=ppt/notesSlides/notesSlide24.xml><?xml version="1.0" encoding="utf-8"?>
-<p:notes xmlns:a="http://schemas.openxmlformats.org/drawingml/2006/main" xmlns:p="http://schemas.openxmlformats.org/presentationml/2006/main" xmlns:r="http://schemas.openxmlformats.org/officeDocument/2006/relationships">
-  <p:cSld>
-    <p:spTree>
-      <p:nvGrpSpPr>
-        <p:cNvPr id="1" name=""/>
-        <p:cNvGrpSpPr/>
-        <p:nvPr/>
-      </p:nvGrpSpPr>
-      <p:grpSpPr>
-        <a:xfrm>
-          <a:off x="0" y="0"/>
-          <a:ext cx="0" cy="0"/>
-          <a:chOff x="0" y="0"/>
-          <a:chExt cx="0" cy="0"/>
-        </a:xfrm>
-      </p:grpSpPr>
-      <p:sp>
-        <p:nvSpPr>
-          <p:cNvPr id="2" name="Slide Image Placeholder 1"/>
-          <p:cNvSpPr>
-            <a:spLocks noGrp="1"/>
-          </p:cNvSpPr>
-          <p:nvPr>
-            <p:ph type="sldImg" idx="2"/>
-          </p:nvPr>
-        </p:nvSpPr>
-        <p:spPr/>
-      </p:sp>
-      <p:sp>
-        <p:nvSpPr>
-          <p:cNvPr id="3" name="Notes Placeholder 2"/>
-          <p:cNvSpPr>
-            <a:spLocks noGrp="1"/>
-          </p:cNvSpPr>
-          <p:nvPr>
-            <p:ph type="body" idx="3" sz="quarter"/>
-          </p:nvPr>
-        </p:nvSpPr>
-        <p:spPr/>
-        <p:txBody>
-          <a:bodyPr/>
-          <a:lstStyle/>
-          <a:p>
-            <a:r>
-              <a:t>Input: Switch major → Software Engineering + AI → Compare plans</a:t>
-            </a:r>
-          </a:p>
-          <a:p>
-            <a:r>
-              <a:t>Output: Current plan and the new one side by side, plus what changes</a:t>
-            </a:r>
-          </a:p>
-          <a:p>
-            <a:r>
-              <a:t>What it means: Lets a student see the cost of switching before committing to it.</a:t>
-            </a:r>
-          </a:p>
-        </p:txBody>
-      </p:sp>
-      <p:sp>
-        <p:nvSpPr>
-          <p:cNvPr id="4" name="Slide Number Placeholder 3"/>
-          <p:cNvSpPr>
-            <a:spLocks noGrp="1"/>
-          </p:cNvSpPr>
-          <p:nvPr>
-            <p:ph type="sldNum" idx="5" sz="quarter"/>
-          </p:nvPr>
-        </p:nvSpPr>
-        <p:spPr/>
-      </p:sp>
-    </p:spTree>
-  </p:cSld>
-  <p:clrMapOvr>
-    <a:masterClrMapping/>
-  </p:clrMapOvr>
-</p:notes>
-</file>
-
-<file path=ppt/notesSlides/notesSlide25.xml><?xml version="1.0" encoding="utf-8"?>
-<p:notes xmlns:a="http://schemas.openxmlformats.org/drawingml/2006/main" xmlns:p="http://schemas.openxmlformats.org/presentationml/2006/main" xmlns:r="http://schemas.openxmlformats.org/officeDocument/2006/relationships">
-  <p:cSld>
-    <p:spTree>
-      <p:nvGrpSpPr>
-        <p:cNvPr id="1" name=""/>
-        <p:cNvGrpSpPr/>
-        <p:nvPr/>
-      </p:nvGrpSpPr>
-      <p:grpSpPr>
-        <a:xfrm>
-          <a:off x="0" y="0"/>
-          <a:ext cx="0" cy="0"/>
-          <a:chOff x="0" y="0"/>
-          <a:chExt cx="0" cy="0"/>
-        </a:xfrm>
-      </p:grpSpPr>
-      <p:sp>
-        <p:nvSpPr>
-          <p:cNvPr id="2" name="Slide Image Placeholder 1"/>
-          <p:cNvSpPr>
-            <a:spLocks noGrp="1"/>
-          </p:cNvSpPr>
-          <p:nvPr>
-            <p:ph type="sldImg" idx="2"/>
-          </p:nvPr>
-        </p:nvSpPr>
-        <p:spPr/>
-      </p:sp>
-      <p:sp>
-        <p:nvSpPr>
-          <p:cNvPr id="3" name="Notes Placeholder 2"/>
-          <p:cNvSpPr>
-            <a:spLocks noGrp="1"/>
-          </p:cNvSpPr>
-          <p:nvPr>
-            <p:ph type="body" idx="3" sz="quarter"/>
-          </p:nvPr>
-        </p:nvSpPr>
-        <p:spPr/>
-        <p:txBody>
-          <a:bodyPr/>
-          <a:lstStyle/>
-          <a:p>
-            <a:r>
-              <a:t>Input: More → Show execution traces → Traces</a:t>
-            </a:r>
-          </a:p>
-          <a:p>
-            <a:r>
-              <a:t>Output: Every turn and action, step by step, with timings</a:t>
-            </a:r>
-          </a:p>
-          <a:p>
-            <a:r>
-              <a:t>What it means: This is the required log of execution traces; the zip has the same data as JSONL and as a readable report.</a:t>
-            </a:r>
-          </a:p>
-        </p:txBody>
-      </p:sp>
-      <p:sp>
-        <p:nvSpPr>
-          <p:cNvPr id="4" name="Slide Number Placeholder 3"/>
-          <p:cNvSpPr>
-            <a:spLocks noGrp="1"/>
-          </p:cNvSpPr>
-          <p:nvPr>
-            <p:ph type="sldNum" idx="5" sz="quarter"/>
-          </p:nvPr>
-        </p:nvSpPr>
-        <p:spPr/>
-      </p:sp>
-    </p:spTree>
-  </p:cSld>
-  <p:clrMapOvr>
-    <a:masterClrMapping/>
-  </p:clrMapOvr>
-</p:notes>
-</file>
-
-<file path=ppt/notesSlides/notesSlide26.xml><?xml version="1.0" encoding="utf-8"?>
-<p:notes xmlns:a="http://schemas.openxmlformats.org/drawingml/2006/main" xmlns:p="http://schemas.openxmlformats.org/presentationml/2006/main" xmlns:r="http://schemas.openxmlformats.org/officeDocument/2006/relationships">
-  <p:cSld>
-    <p:spTree>
-      <p:nvGrpSpPr>
-        <p:cNvPr id="1" name=""/>
-        <p:cNvGrpSpPr/>
-        <p:nvPr/>
-      </p:nvGrpSpPr>
-      <p:grpSpPr>
-        <a:xfrm>
-          <a:off x="0" y="0"/>
-          <a:ext cx="0" cy="0"/>
-          <a:chOff x="0" y="0"/>
-          <a:chExt cx="0" cy="0"/>
-        </a:xfrm>
-      </p:grpSpPr>
-      <p:sp>
-        <p:nvSpPr>
-          <p:cNvPr id="2" name="Slide Image Placeholder 1"/>
-          <p:cNvSpPr>
-            <a:spLocks noGrp="1"/>
-          </p:cNvSpPr>
-          <p:nvPr>
-            <p:ph type="sldImg" idx="2"/>
-          </p:nvPr>
-        </p:nvSpPr>
-        <p:spPr/>
-      </p:sp>
-      <p:sp>
-        <p:nvSpPr>
-          <p:cNvPr id="3" name="Notes Placeholder 2"/>
-          <p:cNvSpPr>
-            <a:spLocks noGrp="1"/>
-          </p:cNvSpPr>
-          <p:nvPr>
-            <p:ph type="body" idx="3" sz="quarter"/>
-          </p:nvPr>
-        </p:nvSpPr>
-        <p:spPr/>
-        <p:txBody>
-          <a:bodyPr/>
-          <a:lstStyle/>
-          <a:p>
-            <a:r>
-              <a:t>Presenter: Talha. Warm the model 10 minutes before (see deliverables/DEMO_GUIDE.md).</a:t>
-            </a:r>
-          </a:p>
-        </p:txBody>
-      </p:sp>
-      <p:sp>
-        <p:nvSpPr>
-          <p:cNvPr id="4" name="Slide Number Placeholder 3"/>
-          <p:cNvSpPr>
-            <a:spLocks noGrp="1"/>
-          </p:cNvSpPr>
-          <p:nvPr>
-            <p:ph type="sldNum" idx="5" sz="quarter"/>
-          </p:nvPr>
-        </p:nvSpPr>
-        <p:spPr/>
-      </p:sp>
-    </p:spTree>
-  </p:cSld>
-  <p:clrMapOvr>
-    <a:masterClrMapping/>
-  </p:clrMapOvr>
-</p:notes>
-</file>
-
-<file path=ppt/notesSlides/notesSlide27.xml><?xml version="1.0" encoding="utf-8"?>
-<p:notes xmlns:a="http://schemas.openxmlformats.org/drawingml/2006/main" xmlns:p="http://schemas.openxmlformats.org/presentationml/2006/main" xmlns:r="http://schemas.openxmlformats.org/officeDocument/2006/relationships">
-  <p:cSld>
-    <p:spTree>
-      <p:nvGrpSpPr>
-        <p:cNvPr id="1" name=""/>
-        <p:cNvGrpSpPr/>
-        <p:nvPr/>
-      </p:nvGrpSpPr>
-      <p:grpSpPr>
-        <a:xfrm>
-          <a:off x="0" y="0"/>
-          <a:ext cx="0" cy="0"/>
-          <a:chOff x="0" y="0"/>
-          <a:chExt cx="0" cy="0"/>
-        </a:xfrm>
-      </p:grpSpPr>
-      <p:sp>
-        <p:nvSpPr>
-          <p:cNvPr id="2" name="Slide Image Placeholder 1"/>
-          <p:cNvSpPr>
-            <a:spLocks noGrp="1"/>
-          </p:cNvSpPr>
-          <p:nvPr>
-            <p:ph type="sldImg" idx="2"/>
-          </p:nvPr>
-        </p:nvSpPr>
-        <p:spPr/>
-      </p:sp>
-      <p:sp>
-        <p:nvSpPr>
-          <p:cNvPr id="3" name="Notes Placeholder 2"/>
-          <p:cNvSpPr>
-            <a:spLocks noGrp="1"/>
-          </p:cNvSpPr>
-          <p:nvPr>
-            <p:ph type="body" idx="3" sz="quarter"/>
-          </p:nvPr>
-        </p:nvSpPr>
-        <p:spPr/>
-        <p:txBody>
-          <a:bodyPr/>
-          <a:lstStyle/>
-          <a:p>
-            <a:r>
-              <a:t>Presenter: everyone can add one line from their own workstream. Keep it to 2 minutes.</a:t>
-            </a:r>
-          </a:p>
-        </p:txBody>
-      </p:sp>
-      <p:sp>
-        <p:nvSpPr>
-          <p:cNvPr id="4" name="Slide Number Placeholder 3"/>
-          <p:cNvSpPr>
-            <a:spLocks noGrp="1"/>
-          </p:cNvSpPr>
-          <p:nvPr>
-            <p:ph type="sldNum" idx="5" sz="quarter"/>
-          </p:nvPr>
-        </p:nvSpPr>
-        <p:spPr/>
-      </p:sp>
-    </p:spTree>
-  </p:cSld>
-  <p:clrMapOvr>
-    <a:masterClrMapping/>
-  </p:clrMapOvr>
-</p:notes>
-</file>
-
-<file path=ppt/notesSlides/notesSlide28.xml><?xml version="1.0" encoding="utf-8"?>
-<p:notes xmlns:a="http://schemas.openxmlformats.org/drawingml/2006/main" xmlns:p="http://schemas.openxmlformats.org/presentationml/2006/main" xmlns:r="http://schemas.openxmlformats.org/officeDocument/2006/relationships">
-  <p:cSld>
-    <p:spTree>
-      <p:nvGrpSpPr>
-        <p:cNvPr id="1" name=""/>
-        <p:cNvGrpSpPr/>
-        <p:nvPr/>
-      </p:nvGrpSpPr>
-      <p:grpSpPr>
-        <a:xfrm>
-          <a:off x="0" y="0"/>
-          <a:ext cx="0" cy="0"/>
-          <a:chOff x="0" y="0"/>
-          <a:chExt cx="0" cy="0"/>
-        </a:xfrm>
-      </p:grpSpPr>
-      <p:sp>
-        <p:nvSpPr>
-          <p:cNvPr id="2" name="Slide Image Placeholder 1"/>
-          <p:cNvSpPr>
-            <a:spLocks noGrp="1"/>
-          </p:cNvSpPr>
-          <p:nvPr>
-            <p:ph type="sldImg" idx="2"/>
-          </p:nvPr>
-        </p:nvSpPr>
-        <p:spPr/>
-      </p:sp>
-      <p:sp>
-        <p:nvSpPr>
-          <p:cNvPr id="3" name="Notes Placeholder 2"/>
-          <p:cNvSpPr>
-            <a:spLocks noGrp="1"/>
-          </p:cNvSpPr>
-          <p:nvPr>
-            <p:ph type="body" idx="3" sz="quarter"/>
-          </p:nvPr>
-        </p:nvSpPr>
-        <p:spPr/>
-        <p:txBody>
-          <a:bodyPr/>
-          <a:lstStyle/>
-          <a:p>
-            <a:r>
-              <a:t>Presenter: Talha. Mention that slow answers are local-model speed; OpenAI is a one-line switch.</a:t>
-            </a:r>
-          </a:p>
-        </p:txBody>
-      </p:sp>
-      <p:sp>
-        <p:nvSpPr>
-          <p:cNvPr id="4" name="Slide Number Placeholder 3"/>
-          <p:cNvSpPr>
-            <a:spLocks noGrp="1"/>
-          </p:cNvSpPr>
-          <p:nvPr>
-            <p:ph type="sldNum" idx="5" sz="quarter"/>
-          </p:nvPr>
-        </p:nvSpPr>
-        <p:spPr/>
-      </p:sp>
-    </p:spTree>
-  </p:cSld>
-  <p:clrMapOvr>
-    <a:masterClrMapping/>
-  </p:clrMapOvr>
-</p:notes>
-</file>
-
-<file path=ppt/notesSlides/notesSlide29.xml><?xml version="1.0" encoding="utf-8"?>
-<p:notes xmlns:a="http://schemas.openxmlformats.org/drawingml/2006/main" xmlns:p="http://schemas.openxmlformats.org/presentationml/2006/main" xmlns:r="http://schemas.openxmlformats.org/officeDocument/2006/relationships">
-  <p:cSld>
-    <p:spTree>
-      <p:nvGrpSpPr>
-        <p:cNvPr id="1" name=""/>
-        <p:cNvGrpSpPr/>
-        <p:nvPr/>
-      </p:nvGrpSpPr>
-      <p:grpSpPr>
-        <a:xfrm>
-          <a:off x="0" y="0"/>
-          <a:ext cx="0" cy="0"/>
-          <a:chOff x="0" y="0"/>
-          <a:chExt cx="0" cy="0"/>
-        </a:xfrm>
-      </p:grpSpPr>
-      <p:sp>
-        <p:nvSpPr>
-          <p:cNvPr id="2" name="Slide Image Placeholder 1"/>
-          <p:cNvSpPr>
-            <a:spLocks noGrp="1"/>
-          </p:cNvSpPr>
-          <p:nvPr>
-            <p:ph type="sldImg" idx="2"/>
-          </p:nvPr>
-        </p:nvSpPr>
-        <p:spPr/>
-      </p:sp>
-      <p:sp>
-        <p:nvSpPr>
-          <p:cNvPr id="3" name="Notes Placeholder 2"/>
-          <p:cNvSpPr>
-            <a:spLocks noGrp="1"/>
-          </p:cNvSpPr>
-          <p:nvPr>
-            <p:ph type="body" idx="3" sz="quarter"/>
-          </p:nvPr>
-        </p:nvSpPr>
-        <p:spPr/>
-        <p:txBody>
-          <a:bodyPr/>
-          <a:lstStyle/>
-          <a:p>
-            <a:r>
-              <a:t>Presenter: Talha. Update after the final run: drop anything the team fixed before the deadline.</a:t>
-            </a:r>
-          </a:p>
-        </p:txBody>
-      </p:sp>
-      <p:sp>
-        <p:nvSpPr>
-          <p:cNvPr id="4" name="Slide Number Placeholder 3"/>
-          <p:cNvSpPr>
-            <a:spLocks noGrp="1"/>
-          </p:cNvSpPr>
-          <p:nvPr>
-            <p:ph type="sldNum" idx="5" sz="quarter"/>
-          </p:nvPr>
-        </p:nvSpPr>
-        <p:spPr/>
-      </p:sp>
-    </p:spTree>
-  </p:cSld>
-  <p:clrMapOvr>
-    <a:masterClrMapping/>
-  </p:clrMapOvr>
-</p:notes>
-</file>
-
-<file path=ppt/notesSlides/notesSlide3.xml><?xml version="1.0" encoding="utf-8"?>
-<p:notes xmlns:a="http://schemas.openxmlformats.org/drawingml/2006/main" xmlns:p="http://schemas.openxmlformats.org/presentationml/2006/main" xmlns:r="http://schemas.openxmlformats.org/officeDocument/2006/relationships">
-  <p:cSld>
-    <p:spTree>
-      <p:nvGrpSpPr>
-        <p:cNvPr id="1" name=""/>
-        <p:cNvGrpSpPr/>
-        <p:nvPr/>
-      </p:nvGrpSpPr>
-      <p:grpSpPr>
-        <a:xfrm>
-          <a:off x="0" y="0"/>
-          <a:ext cx="0" cy="0"/>
-          <a:chOff x="0" y="0"/>
-          <a:chExt cx="0" cy="0"/>
-        </a:xfrm>
-      </p:grpSpPr>
-      <p:sp>
-        <p:nvSpPr>
-          <p:cNvPr id="2" name="Slide Image Placeholder 1"/>
-          <p:cNvSpPr>
-            <a:spLocks noGrp="1"/>
-          </p:cNvSpPr>
-          <p:nvPr>
-            <p:ph type="sldImg" idx="2"/>
-          </p:nvPr>
-        </p:nvSpPr>
-        <p:spPr/>
-      </p:sp>
-      <p:sp>
-        <p:nvSpPr>
-          <p:cNvPr id="3" name="Notes Placeholder 2"/>
-          <p:cNvSpPr>
-            <a:spLocks noGrp="1"/>
-          </p:cNvSpPr>
-          <p:nvPr>
-            <p:ph type="body" idx="3" sz="quarter"/>
-          </p:nvPr>
-        </p:nvSpPr>
-        <p:spPr/>
-        <p:txBody>
-          <a:bodyPr/>
-          <a:lstStyle/>
-          <a:p>
-            <a:r>
-              <a:t>Presenter: Talha. 1 minute.</a:t>
-            </a:r>
-          </a:p>
-          <a:p>
-            <a:r>
-              <a:t>Walk the table top to bottom. Point out that every requirement maps to a specific component</a:t>
-            </a:r>
-          </a:p>
-          <a:p>
-            <a:r>
-              <a:t>and a specific demo moment, so the rest of the talk follows this table.</a:t>
-            </a:r>
-          </a:p>
-        </p:txBody>
-      </p:sp>
-      <p:sp>
-        <p:nvSpPr>
-          <p:cNvPr id="4" name="Slide Number Placeholder 3"/>
-          <p:cNvSpPr>
-            <a:spLocks noGrp="1"/>
-          </p:cNvSpPr>
-          <p:nvPr>
-            <p:ph type="sldNum" idx="5" sz="quarter"/>
-          </p:nvPr>
-        </p:nvSpPr>
-        <p:spPr/>
-      </p:sp>
-    </p:spTree>
-  </p:cSld>
-  <p:clrMapOvr>
-    <a:masterClrMapping/>
-  </p:clrMapOvr>
-</p:notes>
-</file>
-
-<file path=ppt/notesSlides/notesSlide30.xml><?xml version="1.0" encoding="utf-8"?>
-<p:notes xmlns:a="http://schemas.openxmlformats.org/drawingml/2006/main" xmlns:p="http://schemas.openxmlformats.org/presentationml/2006/main" xmlns:r="http://schemas.openxmlformats.org/officeDocument/2006/relationships">
-  <p:cSld>
-    <p:spTree>
-      <p:nvGrpSpPr>
-        <p:cNvPr id="1" name=""/>
-        <p:cNvGrpSpPr/>
-        <p:nvPr/>
-      </p:nvGrpSpPr>
-      <p:grpSpPr>
-        <a:xfrm>
-          <a:off x="0" y="0"/>
-          <a:ext cx="0" cy="0"/>
-          <a:chOff x="0" y="0"/>
-          <a:chExt cx="0" cy="0"/>
-        </a:xfrm>
-      </p:grpSpPr>
-      <p:sp>
-        <p:nvSpPr>
-          <p:cNvPr id="2" name="Slide Image Placeholder 1"/>
-          <p:cNvSpPr>
-            <a:spLocks noGrp="1"/>
-          </p:cNvSpPr>
-          <p:nvPr>
-            <p:ph type="sldImg" idx="2"/>
-          </p:nvPr>
-        </p:nvSpPr>
-        <p:spPr/>
-      </p:sp>
-      <p:sp>
-        <p:nvSpPr>
-          <p:cNvPr id="3" name="Notes Placeholder 2"/>
-          <p:cNvSpPr>
-            <a:spLocks noGrp="1"/>
-          </p:cNvSpPr>
-          <p:nvPr>
-            <p:ph type="body" idx="3" sz="quarter"/>
-          </p:nvPr>
-        </p:nvSpPr>
-        <p:spPr/>
-        <p:txBody>
-          <a:bodyPr/>
-          <a:lstStyle/>
-          <a:p>
-            <a:r>
-              <a:t>Keep the app open on the Traces screen for questions about how an answer was produced.</a:t>
-            </a:r>
-          </a:p>
-        </p:txBody>
-      </p:sp>
-      <p:sp>
-        <p:nvSpPr>
-          <p:cNvPr id="4" name="Slide Number Placeholder 3"/>
-          <p:cNvSpPr>
-            <a:spLocks noGrp="1"/>
-          </p:cNvSpPr>
-          <p:nvPr>
-            <p:ph type="sldNum" idx="5" sz="quarter"/>
-          </p:nvPr>
-        </p:nvSpPr>
-        <p:spPr/>
-      </p:sp>
-    </p:spTree>
-  </p:cSld>
-  <p:clrMapOvr>
-    <a:masterClrMapping/>
-  </p:clrMapOvr>
-</p:notes>
-</file>
-
-<file path=ppt/notesSlides/notesSlide4.xml><?xml version="1.0" encoding="utf-8"?>
-<p:notes xmlns:a="http://schemas.openxmlformats.org/drawingml/2006/main" xmlns:p="http://schemas.openxmlformats.org/presentationml/2006/main" xmlns:r="http://schemas.openxmlformats.org/officeDocument/2006/relationships">
-  <p:cSld>
-    <p:spTree>
-      <p:nvGrpSpPr>
-        <p:cNvPr id="1" name=""/>
-        <p:cNvGrpSpPr/>
-        <p:nvPr/>
-      </p:nvGrpSpPr>
-      <p:grpSpPr>
-        <a:xfrm>
-          <a:off x="0" y="0"/>
-          <a:ext cx="0" cy="0"/>
-          <a:chOff x="0" y="0"/>
-          <a:chExt cx="0" cy="0"/>
-        </a:xfrm>
-      </p:grpSpPr>
-      <p:sp>
-        <p:nvSpPr>
-          <p:cNvPr id="2" name="Slide Image Placeholder 1"/>
-          <p:cNvSpPr>
-            <a:spLocks noGrp="1"/>
-          </p:cNvSpPr>
-          <p:nvPr>
-            <p:ph type="sldImg" idx="2"/>
-          </p:nvPr>
-        </p:nvSpPr>
-        <p:spPr/>
-      </p:sp>
-      <p:sp>
-        <p:nvSpPr>
-          <p:cNvPr id="3" name="Notes Placeholder 2"/>
-          <p:cNvSpPr>
-            <a:spLocks noGrp="1"/>
-          </p:cNvSpPr>
-          <p:nvPr>
-            <p:ph type="body" idx="3" sz="quarter"/>
-          </p:nvPr>
-        </p:nvSpPr>
-        <p:spPr/>
-        <p:txBody>
-          <a:bodyPr/>
-          <a:lstStyle/>
-          <a:p>
-            <a:r>
-              <a:t>Presenter: Jordan (assumptions, data) + Loc (constraints).</a:t>
-            </a:r>
-          </a:p>
-          <a:p>
-            <a:r>
-              <a:t>Constraints on the right are the ones the six verification checks enforce; the demo shows them.</a:t>
-            </a:r>
-          </a:p>
-        </p:txBody>
-      </p:sp>
-      <p:sp>
-        <p:nvSpPr>
-          <p:cNvPr id="4" name="Slide Number Placeholder 3"/>
-          <p:cNvSpPr>
-            <a:spLocks noGrp="1"/>
-          </p:cNvSpPr>
-          <p:nvPr>
-            <p:ph type="sldNum" idx="5" sz="quarter"/>
-          </p:nvPr>
-        </p:nvSpPr>
-        <p:spPr/>
-      </p:sp>
-    </p:spTree>
-  </p:cSld>
-  <p:clrMapOvr>
-    <a:masterClrMapping/>
-  </p:clrMapOvr>
-</p:notes>
-</file>
-
-<file path=ppt/notesSlides/notesSlide5.xml><?xml version="1.0" encoding="utf-8"?>
-<p:notes xmlns:a="http://schemas.openxmlformats.org/drawingml/2006/main" xmlns:p="http://schemas.openxmlformats.org/presentationml/2006/main" xmlns:r="http://schemas.openxmlformats.org/officeDocument/2006/relationships">
-  <p:cSld>
-    <p:spTree>
-      <p:nvGrpSpPr>
-        <p:cNvPr id="1" name=""/>
-        <p:cNvGrpSpPr/>
-        <p:nvPr/>
-      </p:nvGrpSpPr>
-      <p:grpSpPr>
-        <a:xfrm>
-          <a:off x="0" y="0"/>
-          <a:ext cx="0" cy="0"/>
-          <a:chOff x="0" y="0"/>
-          <a:chExt cx="0" cy="0"/>
-        </a:xfrm>
-      </p:grpSpPr>
-      <p:sp>
-        <p:nvSpPr>
-          <p:cNvPr id="2" name="Slide Image Placeholder 1"/>
-          <p:cNvSpPr>
-            <a:spLocks noGrp="1"/>
-          </p:cNvSpPr>
-          <p:nvPr>
-            <p:ph type="sldImg" idx="2"/>
-          </p:nvPr>
-        </p:nvSpPr>
-        <p:spPr/>
-      </p:sp>
-      <p:sp>
-        <p:nvSpPr>
-          <p:cNvPr id="3" name="Notes Placeholder 2"/>
-          <p:cNvSpPr>
-            <a:spLocks noGrp="1"/>
-          </p:cNvSpPr>
-          <p:nvPr>
-            <p:ph type="body" idx="3" sz="quarter"/>
-          </p:nvPr>
-        </p:nvSpPr>
-        <p:spPr/>
-        <p:txBody>
-          <a:bodyPr/>
-          <a:lstStyle/>
-          <a:p>
-            <a:r>
-              <a:t>Presenter: Talha (overview), each owner adds one line about their box.</a:t>
-            </a:r>
-          </a:p>
-          <a:p>
-            <a:r>
-              <a:t>Flow: the student types or clicks in the UI. The UI only talks to the backend through one file,</a:t>
-            </a:r>
-          </a:p>
-          <a:p>
-            <a:r>
-              <a:t>ui/services.py. Chat goes to the orchestrator, which routes the message by intent to exactly one</a:t>
-            </a:r>
-          </a:p>
-          <a:p>
-            <a:r>
-              <a:t>handler. Facts come from SQLite; open-ended questions are answered from Chroma documents by the LLM;</a:t>
-            </a:r>
-          </a:p>
-          <a:p>
-            <a:r>
-              <a:t>plans and the six checks come from a deterministic planner that never calls an LLM.</a:t>
-            </a:r>
-          </a:p>
-          <a:p>
-            <a:r>
-              <a:t>Every step writes a trace record, which is how we produce the execution log.</a:t>
-            </a:r>
-          </a:p>
-        </p:txBody>
-      </p:sp>
-      <p:sp>
-        <p:nvSpPr>
-          <p:cNvPr id="4" name="Slide Number Placeholder 3"/>
-          <p:cNvSpPr>
-            <a:spLocks noGrp="1"/>
-          </p:cNvSpPr>
-          <p:nvPr>
-            <p:ph type="sldNum" idx="5" sz="quarter"/>
-          </p:nvPr>
-        </p:nvSpPr>
-        <p:spPr/>
-      </p:sp>
-    </p:spTree>
-  </p:cSld>
-  <p:clrMapOvr>
-    <a:masterClrMapping/>
-  </p:clrMapOvr>
-</p:notes>
-</file>
-
-<file path=ppt/notesSlides/notesSlide6.xml><?xml version="1.0" encoding="utf-8"?>
-<p:notes xmlns:a="http://schemas.openxmlformats.org/drawingml/2006/main" xmlns:p="http://schemas.openxmlformats.org/presentationml/2006/main" xmlns:r="http://schemas.openxmlformats.org/officeDocument/2006/relationships">
-  <p:cSld>
-    <p:spTree>
-      <p:nvGrpSpPr>
-        <p:cNvPr id="1" name=""/>
-        <p:cNvGrpSpPr/>
-        <p:nvPr/>
-      </p:nvGrpSpPr>
-      <p:grpSpPr>
-        <a:xfrm>
-          <a:off x="0" y="0"/>
-          <a:ext cx="0" cy="0"/>
-          <a:chOff x="0" y="0"/>
-          <a:chExt cx="0" cy="0"/>
-        </a:xfrm>
-      </p:grpSpPr>
-      <p:sp>
-        <p:nvSpPr>
-          <p:cNvPr id="2" name="Slide Image Placeholder 1"/>
-          <p:cNvSpPr>
-            <a:spLocks noGrp="1"/>
-          </p:cNvSpPr>
-          <p:nvPr>
-            <p:ph type="sldImg" idx="2"/>
-          </p:nvPr>
-        </p:nvSpPr>
-        <p:spPr/>
-      </p:sp>
-      <p:sp>
-        <p:nvSpPr>
-          <p:cNvPr id="3" name="Notes Placeholder 2"/>
-          <p:cNvSpPr>
-            <a:spLocks noGrp="1"/>
-          </p:cNvSpPr>
-          <p:nvPr>
-            <p:ph type="body" idx="3" sz="quarter"/>
-          </p:nvPr>
-        </p:nvSpPr>
-        <p:spPr/>
-        <p:txBody>
-          <a:bodyPr/>
-          <a:lstStyle/>
-          <a:p>
-            <a:r>
-              <a:t>Presenter: Talha. The spec asks for "functions of each component and input/output" on the slides;</a:t>
-            </a:r>
-          </a:p>
-          <a:p>
-            <a:r>
-              <a:t>this is that slide. Don't read it; point at two rows and move on.</a:t>
-            </a:r>
-          </a:p>
-        </p:txBody>
-      </p:sp>
-      <p:sp>
-        <p:nvSpPr>
-          <p:cNvPr id="4" name="Slide Number Placeholder 3"/>
-          <p:cNvSpPr>
-            <a:spLocks noGrp="1"/>
-          </p:cNvSpPr>
-          <p:nvPr>
-            <p:ph type="sldNum" idx="5" sz="quarter"/>
-          </p:nvPr>
-        </p:nvSpPr>
-        <p:spPr/>
-      </p:sp>
-    </p:spTree>
-  </p:cSld>
-  <p:clrMapOvr>
-    <a:masterClrMapping/>
-  </p:clrMapOvr>
-</p:notes>
-</file>
-
-<file path=ppt/notesSlides/notesSlide7.xml><?xml version="1.0" encoding="utf-8"?>
-<p:notes xmlns:a="http://schemas.openxmlformats.org/drawingml/2006/main" xmlns:p="http://schemas.openxmlformats.org/presentationml/2006/main" xmlns:r="http://schemas.openxmlformats.org/officeDocument/2006/relationships">
-  <p:cSld>
-    <p:spTree>
-      <p:nvGrpSpPr>
-        <p:cNvPr id="1" name=""/>
-        <p:cNvGrpSpPr/>
-        <p:nvPr/>
-      </p:nvGrpSpPr>
-      <p:grpSpPr>
-        <a:xfrm>
-          <a:off x="0" y="0"/>
-          <a:ext cx="0" cy="0"/>
-          <a:chOff x="0" y="0"/>
-          <a:chExt cx="0" cy="0"/>
-        </a:xfrm>
-      </p:grpSpPr>
-      <p:sp>
-        <p:nvSpPr>
-          <p:cNvPr id="2" name="Slide Image Placeholder 1"/>
-          <p:cNvSpPr>
-            <a:spLocks noGrp="1"/>
-          </p:cNvSpPr>
-          <p:nvPr>
-            <p:ph type="sldImg" idx="2"/>
-          </p:nvPr>
-        </p:nvSpPr>
-        <p:spPr/>
-      </p:sp>
-      <p:sp>
-        <p:nvSpPr>
-          <p:cNvPr id="3" name="Notes Placeholder 2"/>
-          <p:cNvSpPr>
-            <a:spLocks noGrp="1"/>
-          </p:cNvSpPr>
-          <p:nvPr>
-            <p:ph type="body" idx="3" sz="quarter"/>
-          </p:nvPr>
-        </p:nvSpPr>
-        <p:spPr/>
-        <p:txBody>
-          <a:bodyPr/>
-          <a:lstStyle/>
-          <a:p>
-            <a:r>
-              <a:t>Presenter: Kyle (the orchestrator is wired to everyone's interfaces).</a:t>
-            </a:r>
-          </a:p>
-          <a:p>
-            <a:r>
-              <a:t>These contracts were agreed on day one (README "Integration contracts"), which is why the</a:t>
-            </a:r>
-          </a:p>
-          <a:p>
-            <a:r>
-              <a:t>pieces merged with few conflicts.</a:t>
-            </a:r>
-          </a:p>
-        </p:txBody>
-      </p:sp>
-      <p:sp>
-        <p:nvSpPr>
-          <p:cNvPr id="4" name="Slide Number Placeholder 3"/>
-          <p:cNvSpPr>
-            <a:spLocks noGrp="1"/>
-          </p:cNvSpPr>
-          <p:nvPr>
-            <p:ph type="sldNum" idx="5" sz="quarter"/>
-          </p:nvPr>
-        </p:nvSpPr>
-        <p:spPr/>
-      </p:sp>
-    </p:spTree>
-  </p:cSld>
-  <p:clrMapOvr>
-    <a:masterClrMapping/>
-  </p:clrMapOvr>
-</p:notes>
-</file>
-
-<file path=ppt/notesSlides/notesSlide8.xml><?xml version="1.0" encoding="utf-8"?>
-<p:notes xmlns:a="http://schemas.openxmlformats.org/drawingml/2006/main" xmlns:p="http://schemas.openxmlformats.org/presentationml/2006/main" xmlns:r="http://schemas.openxmlformats.org/officeDocument/2006/relationships">
-  <p:cSld>
-    <p:spTree>
-      <p:nvGrpSpPr>
-        <p:cNvPr id="1" name=""/>
-        <p:cNvGrpSpPr/>
-        <p:nvPr/>
-      </p:nvGrpSpPr>
-      <p:grpSpPr>
-        <a:xfrm>
-          <a:off x="0" y="0"/>
-          <a:ext cx="0" cy="0"/>
-          <a:chOff x="0" y="0"/>
-          <a:chExt cx="0" cy="0"/>
-        </a:xfrm>
-      </p:grpSpPr>
-      <p:sp>
-        <p:nvSpPr>
-          <p:cNvPr id="2" name="Slide Image Placeholder 1"/>
-          <p:cNvSpPr>
-            <a:spLocks noGrp="1"/>
-          </p:cNvSpPr>
-          <p:nvPr>
-            <p:ph type="sldImg" idx="2"/>
-          </p:nvPr>
-        </p:nvSpPr>
-        <p:spPr/>
-      </p:sp>
-      <p:sp>
-        <p:nvSpPr>
-          <p:cNvPr id="3" name="Notes Placeholder 2"/>
-          <p:cNvSpPr>
-            <a:spLocks noGrp="1"/>
-          </p:cNvSpPr>
-          <p:nvPr>
-            <p:ph type="body" idx="3" sz="quarter"/>
-          </p:nvPr>
-        </p:nvSpPr>
-        <p:spPr/>
-        <p:txBody>
-          <a:bodyPr/>
-          <a:lstStyle/>
-          <a:p>
-            <a:r>
-              <a:t>Presenter: Jordan.</a:t>
-            </a:r>
-          </a:p>
-          <a:p>
-            <a:r>
-              <a:t>Data comes from the real UTA 2026-27 catalog (degree plans parsed from it); class sections and</a:t>
-            </a:r>
-          </a:p>
-          <a:p>
-            <a:r>
-              <a:t>students are fabricated but consistent with the prerequisites. Documents used to build the embeddings</a:t>
-            </a:r>
-          </a:p>
-          <a:p>
-            <a:r>
-              <a:t>are included in the zip under advisor/seed/.</a:t>
-            </a:r>
-          </a:p>
-        </p:txBody>
-      </p:sp>
-      <p:sp>
-        <p:nvSpPr>
-          <p:cNvPr id="4" name="Slide Number Placeholder 3"/>
-          <p:cNvSpPr>
-            <a:spLocks noGrp="1"/>
-          </p:cNvSpPr>
-          <p:nvPr>
-            <p:ph type="sldNum" idx="5" sz="quarter"/>
-          </p:nvPr>
-        </p:nvSpPr>
-        <p:spPr/>
-      </p:sp>
-    </p:spTree>
-  </p:cSld>
-  <p:clrMapOvr>
-    <a:masterClrMapping/>
-  </p:clrMapOvr>
-</p:notes>
-</file>
-
-<file path=ppt/notesSlides/notesSlide9.xml><?xml version="1.0" encoding="utf-8"?>
-<p:notes xmlns:a="http://schemas.openxmlformats.org/drawingml/2006/main" xmlns:p="http://schemas.openxmlformats.org/presentationml/2006/main" xmlns:r="http://schemas.openxmlformats.org/officeDocument/2006/relationships">
-  <p:cSld>
-    <p:spTree>
-      <p:nvGrpSpPr>
-        <p:cNvPr id="1" name=""/>
-        <p:cNvGrpSpPr/>
-        <p:nvPr/>
-      </p:nvGrpSpPr>
-      <p:grpSpPr>
-        <a:xfrm>
-          <a:off x="0" y="0"/>
-          <a:ext cx="0" cy="0"/>
-          <a:chOff x="0" y="0"/>
-          <a:chExt cx="0" cy="0"/>
-        </a:xfrm>
-      </p:grpSpPr>
-      <p:sp>
-        <p:nvSpPr>
-          <p:cNvPr id="2" name="Slide Image Placeholder 1"/>
-          <p:cNvSpPr>
-            <a:spLocks noGrp="1"/>
-          </p:cNvSpPr>
-          <p:nvPr>
-            <p:ph type="sldImg" idx="2"/>
-          </p:nvPr>
-        </p:nvSpPr>
-        <p:spPr/>
-      </p:sp>
-      <p:sp>
-        <p:nvSpPr>
-          <p:cNvPr id="3" name="Notes Placeholder 2"/>
-          <p:cNvSpPr>
-            <a:spLocks noGrp="1"/>
-          </p:cNvSpPr>
-          <p:nvPr>
-            <p:ph type="body" idx="3" sz="quarter"/>
-          </p:nvPr>
-        </p:nvSpPr>
-        <p:spPr/>
-        <p:txBody>
-          <a:bodyPr/>
-          <a:lstStyle/>
-          <a:p>
-            <a:r>
-              <a:t>Presenter: Talha, with Kyle for routing and Loc for the planner.</a:t>
-            </a:r>
-          </a:p>
-          <a:p>
-            <a:r>
-              <a:t>The assignment asks for the design decisions considered and why we chose ours; this is that slide.</a:t>
-            </a:r>
-          </a:p>
-          <a:p>
-            <a:r>
-              <a:t>Strongest point: plans and the six checks are deterministic code, so the LLM can't invent a</a:t>
-            </a:r>
-          </a:p>
-          <a:p>
-            <a:r>
-              <a:t>prerequisite or a section that doesn't exist.</a:t>
-            </a:r>
-          </a:p>
-        </p:txBody>
-      </p:sp>
-      <p:sp>
-        <p:nvSpPr>
-          <p:cNvPr id="4" name="Slide Number Placeholder 3"/>
-          <p:cNvSpPr>
-            <a:spLocks noGrp="1"/>
-          </p:cNvSpPr>
-          <p:nvPr>
-            <p:ph type="sldNum" idx="5" sz="quarter"/>
-          </p:nvPr>
-        </p:nvSpPr>
-        <p:spPr/>
-      </p:sp>
-    </p:spTree>
-  </p:cSld>
-  <p:clrMapOvr>
-    <a:masterClrMapping/>
-  </p:clrMapOvr>
-</p:notes>
 </file>
 
 <file path=ppt/slideLayouts/slideLayout1.xml><?xml version="1.0" encoding="utf-8"?>
@@ -28441,324 +25761,4 @@
   </a:objectDefaults>
   <a:extraClrSchemeLst/>
 </a:theme>
-</file>
-
-<file path=ppt/theme/theme2.xml><?xml version="1.0" encoding="utf-8"?>
-<a:theme xmlns:a="http://schemas.openxmlformats.org/drawingml/2006/main" name="Office Theme">
-  <a:themeElements>
-    <a:clrScheme name="Office">
-      <a:dk1>
-        <a:sysClr val="windowText" lastClr="000000"/>
-      </a:dk1>
-      <a:lt1>
-        <a:sysClr val="window" lastClr="FFFFFF"/>
-      </a:lt1>
-      <a:dk2>
-        <a:srgbClr val="1F497D"/>
-      </a:dk2>
-      <a:lt2>
-        <a:srgbClr val="EEECE1"/>
-      </a:lt2>
-      <a:accent1>
-        <a:srgbClr val="4F81BD"/>
-      </a:accent1>
-      <a:accent2>
-        <a:srgbClr val="C0504D"/>
-      </a:accent2>
-      <a:accent3>
-        <a:srgbClr val="9BBB59"/>
-      </a:accent3>
-      <a:accent4>
-        <a:srgbClr val="8064A2"/>
-      </a:accent4>
-      <a:accent5>
-        <a:srgbClr val="4BACC6"/>
-      </a:accent5>
-      <a:accent6>
-        <a:srgbClr val="F79646"/>
-      </a:accent6>
-      <a:hlink>
-        <a:srgbClr val="0000FF"/>
-      </a:hlink>
-      <a:folHlink>
-        <a:srgbClr val="800080"/>
-      </a:folHlink>
-    </a:clrScheme>
-    <a:fontScheme name="Office">
-      <a:majorFont>
-        <a:latin typeface="Calibri"/>
-        <a:ea typeface=""/>
-        <a:cs typeface=""/>
-        <a:font script="Jpan" typeface="ＭＳ Ｐゴシック"/>
-        <a:font script="Hang" typeface="맑은 고딕"/>
-        <a:font script="Hans" typeface="宋体"/>
-        <a:font script="Hant" typeface="新細明體"/>
-        <a:font script="Arab" typeface="Times New Roman"/>
-        <a:font script="Hebr" typeface="Times New Roman"/>
-        <a:font script="Thai" typeface="Angsana New"/>
-        <a:font script="Ethi" typeface="Nyala"/>
-        <a:font script="Beng" typeface="Vrinda"/>
-        <a:font script="Gujr" typeface="Shruti"/>
-        <a:font script="Khmr" typeface="MoolBoran"/>
-        <a:font script="Knda" typeface="Tunga"/>
-        <a:font script="Guru" typeface="Raavi"/>
-        <a:font script="Cans" typeface="Euphemia"/>
-        <a:font script="Cher" typeface="Plantagenet Cherokee"/>
-        <a:font script="Yiii" typeface="Microsoft Yi Baiti"/>
-        <a:font script="Tibt" typeface="Microsoft Himalaya"/>
-        <a:font script="Thaa" typeface="MV Boli"/>
-        <a:font script="Deva" typeface="Mangal"/>
-        <a:font script="Telu" typeface="Gautami"/>
-        <a:font script="Taml" typeface="Latha"/>
-        <a:font script="Syrc" typeface="Estrangelo Edessa"/>
-        <a:font script="Orya" typeface="Kalinga"/>
-        <a:font script="Mlym" typeface="Kartika"/>
-        <a:font script="Laoo" typeface="DokChampa"/>
-        <a:font script="Sinh" typeface="Iskoola Pota"/>
-        <a:font script="Mong" typeface="Mongolian Baiti"/>
-        <a:font script="Viet" typeface="Times New Roman"/>
-        <a:font script="Uigh" typeface="Microsoft Uighur"/>
-        <a:font script="Geor" typeface="Sylfaen"/>
-      </a:majorFont>
-      <a:minorFont>
-        <a:latin typeface="Calibri"/>
-        <a:ea typeface=""/>
-        <a:cs typeface=""/>
-        <a:font script="Jpan" typeface="ＭＳ Ｐゴシック"/>
-        <a:font script="Hang" typeface="맑은 고딕"/>
-        <a:font script="Hans" typeface="宋体"/>
-        <a:font script="Hant" typeface="新細明體"/>
-        <a:font script="Arab" typeface="Arial"/>
-        <a:font script="Hebr" typeface="Arial"/>
-        <a:font script="Thai" typeface="Cordia New"/>
-        <a:font script="Ethi" typeface="Nyala"/>
-        <a:font script="Beng" typeface="Vrinda"/>
-        <a:font script="Gujr" typeface="Shruti"/>
-        <a:font script="Khmr" typeface="DaunPenh"/>
-        <a:font script="Knda" typeface="Tunga"/>
-        <a:font script="Guru" typeface="Raavi"/>
-        <a:font script="Cans" typeface="Euphemia"/>
-        <a:font script="Cher" typeface="Plantagenet Cherokee"/>
-        <a:font script="Yiii" typeface="Microsoft Yi Baiti"/>
-        <a:font script="Tibt" typeface="Microsoft Himalaya"/>
-        <a:font script="Thaa" typeface="MV Boli"/>
-        <a:font script="Deva" typeface="Mangal"/>
-        <a:font script="Telu" typeface="Gautami"/>
-        <a:font script="Taml" typeface="Latha"/>
-        <a:font script="Syrc" typeface="Estrangelo Edessa"/>
-        <a:font script="Orya" typeface="Kalinga"/>
-        <a:font script="Mlym" typeface="Kartika"/>
-        <a:font script="Laoo" typeface="DokChampa"/>
-        <a:font script="Sinh" typeface="Iskoola Pota"/>
-        <a:font script="Mong" typeface="Mongolian Baiti"/>
-        <a:font script="Viet" typeface="Arial"/>
-        <a:font script="Uigh" typeface="Microsoft Uighur"/>
-        <a:font script="Geor" typeface="Sylfaen"/>
-      </a:minorFont>
-    </a:fontScheme>
-    <a:fmtScheme name="Office">
-      <a:fillStyleLst>
-        <a:solidFill>
-          <a:schemeClr val="phClr"/>
-        </a:solidFill>
-        <a:gradFill rotWithShape="1">
-          <a:gsLst>
-            <a:gs pos="0">
-              <a:schemeClr val="phClr">
-                <a:tint val="50000"/>
-                <a:satMod val="300000"/>
-              </a:schemeClr>
-            </a:gs>
-            <a:gs pos="35000">
-              <a:schemeClr val="phClr">
-                <a:tint val="37000"/>
-                <a:satMod val="300000"/>
-              </a:schemeClr>
-            </a:gs>
-            <a:gs pos="100000">
-              <a:schemeClr val="phClr">
-                <a:tint val="15000"/>
-                <a:satMod val="350000"/>
-              </a:schemeClr>
-            </a:gs>
-          </a:gsLst>
-          <a:lin ang="16200000" scaled="1"/>
-        </a:gradFill>
-        <a:gradFill rotWithShape="1">
-          <a:gsLst>
-            <a:gs pos="0">
-              <a:schemeClr val="phClr">
-                <a:tint val="100000"/>
-                <a:shade val="100000"/>
-                <a:satMod val="130000"/>
-              </a:schemeClr>
-            </a:gs>
-            <a:gs pos="100000">
-              <a:schemeClr val="phClr">
-                <a:tint val="50000"/>
-                <a:shade val="100000"/>
-                <a:satMod val="350000"/>
-              </a:schemeClr>
-            </a:gs>
-          </a:gsLst>
-          <a:lin ang="16200000" scaled="0"/>
-        </a:gradFill>
-      </a:fillStyleLst>
-      <a:lnStyleLst>
-        <a:ln w="9525" cap="flat" cmpd="sng" algn="ctr">
-          <a:solidFill>
-            <a:schemeClr val="phClr">
-              <a:shade val="95000"/>
-              <a:satMod val="105000"/>
-            </a:schemeClr>
-          </a:solidFill>
-          <a:prstDash val="solid"/>
-        </a:ln>
-        <a:ln w="25400" cap="flat" cmpd="sng" algn="ctr">
-          <a:solidFill>
-            <a:schemeClr val="phClr"/>
-          </a:solidFill>
-          <a:prstDash val="solid"/>
-        </a:ln>
-        <a:ln w="38100" cap="flat" cmpd="sng" algn="ctr">
-          <a:solidFill>
-            <a:schemeClr val="phClr"/>
-          </a:solidFill>
-          <a:prstDash val="solid"/>
-        </a:ln>
-      </a:lnStyleLst>
-      <a:effectStyleLst>
-        <a:effectStyle>
-          <a:effectLst>
-            <a:outerShdw blurRad="40000" dist="20000" dir="5400000" rotWithShape="0">
-              <a:srgbClr val="000000">
-                <a:alpha val="38000"/>
-              </a:srgbClr>
-            </a:outerShdw>
-          </a:effectLst>
-        </a:effectStyle>
-        <a:effectStyle>
-          <a:effectLst>
-            <a:outerShdw blurRad="40000" dist="23000" dir="5400000" rotWithShape="0">
-              <a:srgbClr val="000000">
-                <a:alpha val="35000"/>
-              </a:srgbClr>
-            </a:outerShdw>
-          </a:effectLst>
-        </a:effectStyle>
-        <a:effectStyle>
-          <a:effectLst>
-            <a:outerShdw blurRad="40000" dist="23000" dir="5400000" rotWithShape="0">
-              <a:srgbClr val="000000">
-                <a:alpha val="35000"/>
-              </a:srgbClr>
-            </a:outerShdw>
-          </a:effectLst>
-          <a:scene3d>
-            <a:camera prst="orthographicFront">
-              <a:rot lat="0" lon="0" rev="0"/>
-            </a:camera>
-            <a:lightRig rig="threePt" dir="t">
-              <a:rot lat="0" lon="0" rev="1200000"/>
-            </a:lightRig>
-          </a:scene3d>
-          <a:sp3d>
-            <a:bevelT w="63500" h="25400"/>
-          </a:sp3d>
-        </a:effectStyle>
-      </a:effectStyleLst>
-      <a:bgFillStyleLst>
-        <a:solidFill>
-          <a:schemeClr val="phClr"/>
-        </a:solidFill>
-        <a:gradFill rotWithShape="1">
-          <a:gsLst>
-            <a:gs pos="0">
-              <a:schemeClr val="phClr">
-                <a:tint val="40000"/>
-                <a:satMod val="350000"/>
-              </a:schemeClr>
-            </a:gs>
-            <a:gs pos="40000">
-              <a:schemeClr val="phClr">
-                <a:tint val="45000"/>
-                <a:shade val="99000"/>
-                <a:satMod val="350000"/>
-              </a:schemeClr>
-            </a:gs>
-            <a:gs pos="100000">
-              <a:schemeClr val="phClr">
-                <a:shade val="20000"/>
-                <a:satMod val="255000"/>
-              </a:schemeClr>
-            </a:gs>
-          </a:gsLst>
-          <a:path path="circle">
-            <a:fillToRect l="50000" t="-80000" r="50000" b="180000"/>
-          </a:path>
-        </a:gradFill>
-        <a:gradFill rotWithShape="1">
-          <a:gsLst>
-            <a:gs pos="0">
-              <a:schemeClr val="phClr">
-                <a:tint val="80000"/>
-                <a:satMod val="300000"/>
-              </a:schemeClr>
-            </a:gs>
-            <a:gs pos="100000">
-              <a:schemeClr val="phClr">
-                <a:shade val="30000"/>
-                <a:satMod val="200000"/>
-              </a:schemeClr>
-            </a:gs>
-          </a:gsLst>
-          <a:path path="circle">
-            <a:fillToRect l="50000" t="50000" r="50000" b="50000"/>
-          </a:path>
-        </a:gradFill>
-      </a:bgFillStyleLst>
-    </a:fmtScheme>
-  </a:themeElements>
-  <a:objectDefaults>
-    <a:spDef>
-      <a:spPr/>
-      <a:bodyPr/>
-      <a:lstStyle/>
-      <a:style>
-        <a:lnRef idx="1">
-          <a:schemeClr val="accent1"/>
-        </a:lnRef>
-        <a:fillRef idx="3">
-          <a:schemeClr val="accent1"/>
-        </a:fillRef>
-        <a:effectRef idx="2">
-          <a:schemeClr val="accent1"/>
-        </a:effectRef>
-        <a:fontRef idx="minor">
-          <a:schemeClr val="lt1"/>
-        </a:fontRef>
-      </a:style>
-    </a:spDef>
-    <a:lnDef>
-      <a:spPr/>
-      <a:bodyPr/>
-      <a:lstStyle/>
-      <a:style>
-        <a:lnRef idx="2">
-          <a:schemeClr val="accent1"/>
-        </a:lnRef>
-        <a:fillRef idx="0">
-          <a:schemeClr val="accent1"/>
-        </a:fillRef>
-        <a:effectRef idx="1">
-          <a:schemeClr val="accent1"/>
-        </a:effectRef>
-        <a:fontRef idx="minor">
-          <a:schemeClr val="tx1"/>
-        </a:fontRef>
-      </a:style>
-    </a:lnDef>
-  </a:objectDefaults>
-  <a:extraClrSchemeLst/>
-</a:theme>
 </file>
</xml_diff>